<commit_message>
Nye modeller features og assets
</commit_message>
<xml_diff>
--- a/Præsentation3.pptx
+++ b/Præsentation3.pptx
@@ -221,7 +221,7 @@
           <a:p>
             <a:fld id="{C68F9E11-F642-4BF2-B4DC-AF7D35EA7551}" type="datetimeFigureOut">
               <a:rPr lang="en-GB" smtClean="0"/>
-              <a:t>22/04/2026</a:t>
+              <a:t>25/04/2026</a:t>
             </a:fld>
             <a:endParaRPr lang="en-GB"/>
           </a:p>
@@ -402,7 +402,7 @@
           <a:p>
             <a:fld id="{CD72A38B-F9FA-4036-A084-652409E98F08}" type="datetimeFigureOut">
               <a:rPr lang="en-GB" smtClean="0"/>
-              <a:t>22/04/2026</a:t>
+              <a:t>25/04/2026</a:t>
             </a:fld>
             <a:endParaRPr lang="en-GB"/>
           </a:p>
@@ -1115,7 +1115,7 @@
           <a:p>
             <a:fld id="{C1939100-E010-4143-9AE4-D4252D808A58}" type="datetime1">
               <a:rPr lang="da-DK" smtClean="0"/>
-              <a:t>22-04-2026</a:t>
+              <a:t>25-04-2026</a:t>
             </a:fld>
             <a:endParaRPr lang="da-DK" dirty="0"/>
           </a:p>
@@ -1302,7 +1302,7 @@
           <a:p>
             <a:fld id="{91CDCA84-DC5F-4F54-86C4-3A3F71268220}" type="datetime1">
               <a:rPr lang="da-DK" smtClean="0"/>
-              <a:t>22-04-2026</a:t>
+              <a:t>25-04-2026</a:t>
             </a:fld>
             <a:endParaRPr lang="da-DK" dirty="0"/>
           </a:p>
@@ -1423,7 +1423,7 @@
           <a:p>
             <a:fld id="{69A4F1A1-6766-441F-9F00-E93D521E50F3}" type="datetime1">
               <a:rPr lang="da-DK" smtClean="0"/>
-              <a:t>22-04-2026</a:t>
+              <a:t>25-04-2026</a:t>
             </a:fld>
             <a:endParaRPr lang="da-DK" dirty="0"/>
           </a:p>
@@ -1518,7 +1518,7 @@
           <a:p>
             <a:fld id="{64A4256D-1A02-4FDD-AA38-4D8490006FD4}" type="datetime1">
               <a:rPr lang="da-DK" smtClean="0"/>
-              <a:t>22-04-2026</a:t>
+              <a:t>25-04-2026</a:t>
             </a:fld>
             <a:endParaRPr lang="da-DK" dirty="0"/>
           </a:p>
@@ -1630,7 +1630,7 @@
           <a:p>
             <a:fld id="{60A4E1C7-F811-4F51-BDA9-17EBB9618420}" type="datetime1">
               <a:rPr lang="da-DK" smtClean="0"/>
-              <a:t>22-04-2026</a:t>
+              <a:t>25-04-2026</a:t>
             </a:fld>
             <a:endParaRPr lang="da-DK" dirty="0"/>
           </a:p>
@@ -2133,7 +2133,7 @@
           <a:p>
             <a:fld id="{2AD08259-92F1-4C32-A312-C73CE2167131}" type="datetime1">
               <a:rPr lang="da-DK" smtClean="0"/>
-              <a:t>22-04-2026</a:t>
+              <a:t>25-04-2026</a:t>
             </a:fld>
             <a:endParaRPr lang="da-DK" dirty="0"/>
           </a:p>
@@ -2435,7 +2435,7 @@
           <a:p>
             <a:fld id="{44775082-3ECA-430B-8AFE-6C0254841555}" type="datetime1">
               <a:rPr lang="da-DK" smtClean="0"/>
-              <a:t>22-04-2026</a:t>
+              <a:t>25-04-2026</a:t>
             </a:fld>
             <a:endParaRPr lang="da-DK" dirty="0"/>
           </a:p>
@@ -2736,7 +2736,7 @@
           <a:p>
             <a:fld id="{F9B52271-5E3D-4E06-BC0A-7C1022408CCC}" type="datetime1">
               <a:rPr lang="da-DK" smtClean="0"/>
-              <a:t>22-04-2026</a:t>
+              <a:t>25-04-2026</a:t>
             </a:fld>
             <a:endParaRPr lang="da-DK" dirty="0"/>
           </a:p>
@@ -2929,7 +2929,7 @@
           <a:p>
             <a:fld id="{1E1593FE-D5FA-4E0E-8FFF-8F10D57A1EC1}" type="datetime1">
               <a:rPr lang="da-DK" smtClean="0"/>
-              <a:t>22-04-2026</a:t>
+              <a:t>25-04-2026</a:t>
             </a:fld>
             <a:endParaRPr lang="da-DK" dirty="0"/>
           </a:p>
@@ -3903,7 +3903,7 @@
           <a:p>
             <a:fld id="{7B4776D0-1C54-4AA2-B3C6-9EDE760637A2}" type="datetime1">
               <a:rPr lang="da-DK" smtClean="0"/>
-              <a:t>22-04-2026</a:t>
+              <a:t>25-04-2026</a:t>
             </a:fld>
             <a:endParaRPr lang="da-DK" dirty="0"/>
           </a:p>
@@ -4085,7 +4085,7 @@
           <a:p>
             <a:fld id="{5BA219F3-EBEC-4665-8131-8E409DE99ADE}" type="datetime1">
               <a:rPr lang="da-DK" smtClean="0"/>
-              <a:t>22-04-2026</a:t>
+              <a:t>25-04-2026</a:t>
             </a:fld>
             <a:endParaRPr lang="da-DK" dirty="0"/>
           </a:p>
@@ -5100,7 +5100,7 @@
           <a:p>
             <a:fld id="{43EC545E-1E39-4013-A907-D4C8F3E3A8B4}" type="datetime1">
               <a:rPr lang="da-DK" smtClean="0"/>
-              <a:t>22-04-2026</a:t>
+              <a:t>25-04-2026</a:t>
             </a:fld>
             <a:endParaRPr lang="da-DK" dirty="0"/>
           </a:p>
@@ -5265,7 +5265,7 @@
           <a:p>
             <a:fld id="{D502B9D2-A192-42E6-9020-F3EAB57A6114}" type="datetime1">
               <a:rPr lang="da-DK" smtClean="0"/>
-              <a:t>22-04-2026</a:t>
+              <a:t>25-04-2026</a:t>
             </a:fld>
             <a:endParaRPr lang="da-DK" dirty="0"/>
           </a:p>
@@ -5607,7 +5607,7 @@
           <a:p>
             <a:fld id="{4F049CB1-FD99-442F-B632-7502FA9A3C45}" type="datetime1">
               <a:rPr lang="da-DK" smtClean="0"/>
-              <a:t>22-04-2026</a:t>
+              <a:t>25-04-2026</a:t>
             </a:fld>
             <a:endParaRPr lang="da-DK" dirty="0"/>
           </a:p>
@@ -6120,7 +6120,7 @@
           <a:p>
             <a:fld id="{F2C56D48-5B3F-4C59-A9D8-68D0A39D6CD2}" type="datetime1">
               <a:rPr lang="da-DK" smtClean="0"/>
-              <a:t>22-04-2026</a:t>
+              <a:t>25-04-2026</a:t>
             </a:fld>
             <a:endParaRPr lang="da-DK" dirty="0"/>
           </a:p>
@@ -6271,7 +6271,7 @@
           <a:p>
             <a:fld id="{3015CAA0-42C1-41A7-86CE-BA2D8D2C2EF0}" type="datetime1">
               <a:rPr lang="da-DK" smtClean="0"/>
-              <a:t>22-04-2026</a:t>
+              <a:t>25-04-2026</a:t>
             </a:fld>
             <a:endParaRPr lang="da-DK" dirty="0"/>
           </a:p>
@@ -6578,7 +6578,7 @@
           <a:p>
             <a:fld id="{CAEB073E-A784-466B-98E2-8BDE3F08A73A}" type="datetime1">
               <a:rPr lang="da-DK" smtClean="0"/>
-              <a:t>22-04-2026</a:t>
+              <a:t>25-04-2026</a:t>
             </a:fld>
             <a:endParaRPr lang="da-DK" dirty="0"/>
           </a:p>
@@ -6841,7 +6841,7 @@
           <a:p>
             <a:fld id="{2ABA92E9-ED6E-4E2D-9447-0E7DB3FDA12F}" type="datetime1">
               <a:rPr lang="da-DK" smtClean="0"/>
-              <a:t>22-04-2026</a:t>
+              <a:t>25-04-2026</a:t>
             </a:fld>
             <a:endParaRPr lang="da-DK" dirty="0"/>
           </a:p>
@@ -7104,7 +7104,7 @@
           <a:p>
             <a:fld id="{BFDD7C1D-A477-4C13-845F-4C5AC4DEDF20}" type="datetime1">
               <a:rPr lang="da-DK" smtClean="0"/>
-              <a:t>22-04-2026</a:t>
+              <a:t>25-04-2026</a:t>
             </a:fld>
             <a:endParaRPr lang="da-DK" dirty="0"/>
           </a:p>
@@ -7367,7 +7367,7 @@
           <a:p>
             <a:fld id="{AD0B22DB-13B5-430F-8C6F-F11F20BF0D18}" type="datetime1">
               <a:rPr lang="da-DK" smtClean="0"/>
-              <a:t>22-04-2026</a:t>
+              <a:t>25-04-2026</a:t>
             </a:fld>
             <a:endParaRPr lang="da-DK" dirty="0"/>
           </a:p>
@@ -7630,7 +7630,7 @@
           <a:p>
             <a:fld id="{E66DEF25-ACCC-4F90-BF7A-77B4DDE7678A}" type="datetime1">
               <a:rPr lang="da-DK" smtClean="0"/>
-              <a:t>22-04-2026</a:t>
+              <a:t>25-04-2026</a:t>
             </a:fld>
             <a:endParaRPr lang="da-DK" dirty="0"/>
           </a:p>
@@ -7812,7 +7812,7 @@
           <a:p>
             <a:fld id="{C9E8B2A5-1DCC-48EA-93B7-A2D65B200BE6}" type="datetime1">
               <a:rPr lang="da-DK" smtClean="0"/>
-              <a:t>22-04-2026</a:t>
+              <a:t>25-04-2026</a:t>
             </a:fld>
             <a:endParaRPr lang="da-DK" dirty="0"/>
           </a:p>
@@ -8270,7 +8270,7 @@
           <a:p>
             <a:fld id="{6E5195FB-CC23-4662-BC95-6C4057FF490E}" type="datetime1">
               <a:rPr lang="da-DK" smtClean="0"/>
-              <a:t>22-04-2026</a:t>
+              <a:t>25-04-2026</a:t>
             </a:fld>
             <a:endParaRPr lang="da-DK" dirty="0"/>
           </a:p>
@@ -13055,7 +13055,7 @@
           <a:p>
             <a:fld id="{FA96AD4B-435A-4D0A-87A0-F4000646B7B6}" type="datetime1">
               <a:rPr lang="da-DK" smtClean="0"/>
-              <a:t>22-04-2026</a:t>
+              <a:t>25-04-2026</a:t>
             </a:fld>
             <a:endParaRPr lang="da-DK" dirty="0"/>
           </a:p>
@@ -13469,7 +13469,7 @@
           <a:p>
             <a:fld id="{850C8D61-CF2F-4293-9A1F-6B0C79C373C6}" type="datetime1">
               <a:rPr lang="da-DK" smtClean="0"/>
-              <a:t>22-04-2026</a:t>
+              <a:t>25-04-2026</a:t>
             </a:fld>
             <a:endParaRPr lang="da-DK" dirty="0"/>
           </a:p>
@@ -13799,7 +13799,7 @@
           <a:p>
             <a:fld id="{34D99FEB-2FC3-4FA6-9F36-280592A4EBA0}" type="datetime1">
               <a:rPr lang="da-DK" smtClean="0"/>
-              <a:t>22-04-2026</a:t>
+              <a:t>25-04-2026</a:t>
             </a:fld>
             <a:endParaRPr lang="da-DK" dirty="0"/>
           </a:p>
@@ -14191,7 +14191,7 @@
           <a:p>
             <a:fld id="{A255E55A-4CBD-4745-9CAA-603B15E40F2A}" type="datetime1">
               <a:rPr lang="da-DK" smtClean="0"/>
-              <a:t>22-04-2026</a:t>
+              <a:t>25-04-2026</a:t>
             </a:fld>
             <a:endParaRPr lang="da-DK" dirty="0"/>
           </a:p>
@@ -14411,7 +14411,7 @@
           <a:p>
             <a:fld id="{A40A2488-620E-4717-952D-4163044243D3}" type="datetime1">
               <a:rPr lang="da-DK" smtClean="0"/>
-              <a:t>22-04-2026</a:t>
+              <a:t>25-04-2026</a:t>
             </a:fld>
             <a:endParaRPr lang="da-DK" dirty="0"/>
           </a:p>
@@ -14664,7 +14664,7 @@
           <a:p>
             <a:fld id="{57B94B7A-445E-4B32-AE33-AE6AFA618291}" type="datetime1">
               <a:rPr lang="da-DK" smtClean="0"/>
-              <a:t>22-04-2026</a:t>
+              <a:t>25-04-2026</a:t>
             </a:fld>
             <a:endParaRPr lang="da-DK" dirty="0"/>
           </a:p>
@@ -14909,7 +14909,7 @@
           <a:p>
             <a:fld id="{2CC1B346-6D22-4E2E-9D8A-0DE526CBF6C5}" type="datetime1">
               <a:rPr lang="da-DK" smtClean="0"/>
-              <a:t>22-04-2026</a:t>
+              <a:t>25-04-2026</a:t>
             </a:fld>
             <a:endParaRPr lang="da-DK" dirty="0"/>
           </a:p>
@@ -15336,7 +15336,7 @@
           <a:p>
             <a:fld id="{7A056A0C-BA80-48B5-9C35-4A96F80DBB77}" type="datetime1">
               <a:rPr lang="da-DK" smtClean="0"/>
-              <a:t>22-04-2026</a:t>
+              <a:t>25-04-2026</a:t>
             </a:fld>
             <a:endParaRPr lang="da-DK" dirty="0"/>
           </a:p>
@@ -15748,7 +15748,7 @@
           <a:p>
             <a:fld id="{58B270F0-8F8E-46A3-BFFE-96163F9D413B}" type="datetime1">
               <a:rPr lang="da-DK" smtClean="0"/>
-              <a:t>22-04-2026</a:t>
+              <a:t>25-04-2026</a:t>
             </a:fld>
             <a:endParaRPr lang="da-DK" dirty="0"/>
           </a:p>
@@ -16077,7 +16077,7 @@
           <a:p>
             <a:fld id="{F6FFD22D-F364-4E9E-AF9D-75D698CDD634}" type="datetime1">
               <a:rPr lang="da-DK" smtClean="0"/>
-              <a:t>22-04-2026</a:t>
+              <a:t>25-04-2026</a:t>
             </a:fld>
             <a:endParaRPr lang="da-DK" dirty="0"/>
           </a:p>
@@ -16193,8 +16193,50 @@
           <a:p>
             <a:r>
               <a:rPr lang="da-DK" dirty="0"/>
-              <a:t>Feature data:</a:t>
-            </a:r>
+              <a:t>Data </a:t>
+            </a:r>
+            <a:r>
+              <a:rPr lang="da-DK" dirty="0" err="1"/>
+              <a:t>pull</a:t>
+            </a:r>
+            <a:r>
+              <a:rPr lang="da-DK" dirty="0"/>
+              <a:t> from Yahoo and FRED Databases</a:t>
+            </a:r>
+          </a:p>
+          <a:p>
+            <a:r>
+              <a:rPr lang="da-DK" dirty="0" err="1"/>
+              <a:t>Includes</a:t>
+            </a:r>
+            <a:r>
+              <a:rPr lang="da-DK" dirty="0"/>
+              <a:t> </a:t>
+            </a:r>
+            <a:r>
+              <a:rPr lang="da-DK" dirty="0" err="1"/>
+              <a:t>macro</a:t>
+            </a:r>
+            <a:r>
+              <a:rPr lang="da-DK" dirty="0"/>
+              <a:t> variables, and </a:t>
+            </a:r>
+            <a:r>
+              <a:rPr lang="da-DK" dirty="0" err="1"/>
+              <a:t>market</a:t>
+            </a:r>
+            <a:r>
+              <a:rPr lang="da-DK" dirty="0"/>
+              <a:t> data.</a:t>
+            </a:r>
+          </a:p>
+          <a:p>
+            <a:pPr lvl="1"/>
+            <a:r>
+              <a:rPr lang="da-DK"/>
+              <a:t>Inflation, </a:t>
+            </a:r>
+            <a:endParaRPr lang="da-DK" dirty="0"/>
           </a:p>
         </p:txBody>
       </p:sp>
@@ -16221,7 +16263,7 @@
           <a:p>
             <a:fld id="{A40A2488-620E-4717-952D-4163044243D3}" type="datetime1">
               <a:rPr lang="da-DK" smtClean="0"/>
-              <a:t>22-04-2026</a:t>
+              <a:t>25-04-2026</a:t>
             </a:fld>
             <a:endParaRPr lang="da-DK" dirty="0"/>
           </a:p>

</xml_diff>

<commit_message>
Nye ting til alting idgaf
</commit_message>
<xml_diff>
--- a/Præsentation3.pptx
+++ b/Præsentation3.pptx
@@ -5,15 +5,24 @@
     <p:sldMasterId id="2147483658" r:id="rId1"/>
   </p:sldMasterIdLst>
   <p:notesMasterIdLst>
-    <p:notesMasterId r:id="rId5"/>
+    <p:notesMasterId r:id="rId14"/>
   </p:notesMasterIdLst>
   <p:handoutMasterIdLst>
-    <p:handoutMasterId r:id="rId6"/>
+    <p:handoutMasterId r:id="rId15"/>
   </p:handoutMasterIdLst>
   <p:sldIdLst>
     <p:sldId id="441" r:id="rId2"/>
     <p:sldId id="450" r:id="rId3"/>
     <p:sldId id="451" r:id="rId4"/>
+    <p:sldId id="452" r:id="rId5"/>
+    <p:sldId id="453" r:id="rId6"/>
+    <p:sldId id="454" r:id="rId7"/>
+    <p:sldId id="455" r:id="rId8"/>
+    <p:sldId id="456" r:id="rId9"/>
+    <p:sldId id="457" r:id="rId10"/>
+    <p:sldId id="459" r:id="rId11"/>
+    <p:sldId id="458" r:id="rId12"/>
+    <p:sldId id="460" r:id="rId13"/>
   </p:sldIdLst>
   <p:sldSz cx="12192000" cy="6858000"/>
   <p:notesSz cx="6858000" cy="9144000"/>
@@ -15931,6 +15940,616 @@
 </p:sld>
 </file>
 
+<file path=ppt/slides/slide10.xml><?xml version="1.0" encoding="utf-8"?>
+<p:sld xmlns:a="http://schemas.openxmlformats.org/drawingml/2006/main" xmlns:r="http://schemas.openxmlformats.org/officeDocument/2006/relationships" xmlns:p="http://schemas.openxmlformats.org/presentationml/2006/main">
+  <p:cSld>
+    <p:spTree>
+      <p:nvGrpSpPr>
+        <p:cNvPr id="1" name=""/>
+        <p:cNvGrpSpPr/>
+        <p:nvPr/>
+      </p:nvGrpSpPr>
+      <p:grpSpPr>
+        <a:xfrm>
+          <a:off x="0" y="0"/>
+          <a:ext cx="0" cy="0"/>
+          <a:chOff x="0" y="0"/>
+          <a:chExt cx="0" cy="0"/>
+        </a:xfrm>
+      </p:grpSpPr>
+      <p:sp>
+        <p:nvSpPr>
+          <p:cNvPr id="2" name="Titel 1">
+            <a:extLst>
+              <a:ext uri="{FF2B5EF4-FFF2-40B4-BE49-F238E27FC236}">
+                <a16:creationId xmlns:a16="http://schemas.microsoft.com/office/drawing/2014/main" id="{7144D44C-B657-0351-D836-DCD28BEE1AF6}"/>
+              </a:ext>
+            </a:extLst>
+          </p:cNvPr>
+          <p:cNvSpPr>
+            <a:spLocks noGrp="1"/>
+          </p:cNvSpPr>
+          <p:nvPr>
+            <p:ph type="title"/>
+          </p:nvPr>
+        </p:nvSpPr>
+        <p:spPr/>
+        <p:txBody>
+          <a:bodyPr/>
+          <a:lstStyle/>
+          <a:p>
+            <a:r>
+              <a:rPr lang="da-DK" dirty="0" err="1"/>
+              <a:t>Kmeans</a:t>
+            </a:r>
+            <a:r>
+              <a:rPr lang="da-DK" dirty="0"/>
+              <a:t> 2/2</a:t>
+            </a:r>
+          </a:p>
+        </p:txBody>
+      </p:sp>
+      <p:pic>
+        <p:nvPicPr>
+          <p:cNvPr id="7" name="Pladsholder til indhold 6">
+            <a:extLst>
+              <a:ext uri="{FF2B5EF4-FFF2-40B4-BE49-F238E27FC236}">
+                <a16:creationId xmlns:a16="http://schemas.microsoft.com/office/drawing/2014/main" id="{BD65AD3C-B94E-1428-EA57-08E65485A75D}"/>
+              </a:ext>
+            </a:extLst>
+          </p:cNvPr>
+          <p:cNvPicPr>
+            <a:picLocks noGrp="1" noChangeAspect="1"/>
+          </p:cNvPicPr>
+          <p:nvPr>
+            <p:ph idx="1"/>
+          </p:nvPr>
+        </p:nvPicPr>
+        <p:blipFill>
+          <a:blip r:embed="rId2"/>
+          <a:stretch>
+            <a:fillRect/>
+          </a:stretch>
+        </p:blipFill>
+        <p:spPr>
+          <a:xfrm>
+            <a:off x="4134496" y="1626752"/>
+            <a:ext cx="7009591" cy="4610534"/>
+          </a:xfrm>
+          <a:prstGeom prst="rect">
+            <a:avLst/>
+          </a:prstGeom>
+        </p:spPr>
+      </p:pic>
+      <p:sp>
+        <p:nvSpPr>
+          <p:cNvPr id="4" name="Pladsholder til dato 3">
+            <a:extLst>
+              <a:ext uri="{FF2B5EF4-FFF2-40B4-BE49-F238E27FC236}">
+                <a16:creationId xmlns:a16="http://schemas.microsoft.com/office/drawing/2014/main" id="{FC0E5C16-2978-C100-38C7-6DC88F3F5639}"/>
+              </a:ext>
+            </a:extLst>
+          </p:cNvPr>
+          <p:cNvSpPr>
+            <a:spLocks noGrp="1"/>
+          </p:cNvSpPr>
+          <p:nvPr>
+            <p:ph type="dt" sz="half" idx="10"/>
+          </p:nvPr>
+        </p:nvSpPr>
+        <p:spPr/>
+        <p:txBody>
+          <a:bodyPr/>
+          <a:lstStyle/>
+          <a:p>
+            <a:fld id="{A40A2488-620E-4717-952D-4163044243D3}" type="datetime1">
+              <a:rPr lang="da-DK" smtClean="0"/>
+              <a:t>25-04-2026</a:t>
+            </a:fld>
+            <a:endParaRPr lang="da-DK" dirty="0"/>
+          </a:p>
+        </p:txBody>
+      </p:sp>
+      <p:sp>
+        <p:nvSpPr>
+          <p:cNvPr id="5" name="Pladsholder til slidenummer 4">
+            <a:extLst>
+              <a:ext uri="{FF2B5EF4-FFF2-40B4-BE49-F238E27FC236}">
+                <a16:creationId xmlns:a16="http://schemas.microsoft.com/office/drawing/2014/main" id="{0BE17EB4-1088-CEAD-5322-0261AE2A27FD}"/>
+              </a:ext>
+            </a:extLst>
+          </p:cNvPr>
+          <p:cNvSpPr>
+            <a:spLocks noGrp="1"/>
+          </p:cNvSpPr>
+          <p:nvPr>
+            <p:ph type="sldNum" sz="quarter" idx="12"/>
+          </p:nvPr>
+        </p:nvSpPr>
+        <p:spPr/>
+        <p:txBody>
+          <a:bodyPr/>
+          <a:lstStyle/>
+          <a:p>
+            <a:fld id="{091A926C-488A-4E3E-9C21-57CAA120E114}" type="slidenum">
+              <a:rPr lang="da-DK" smtClean="0"/>
+              <a:t>10</a:t>
+            </a:fld>
+            <a:endParaRPr lang="da-DK" dirty="0"/>
+          </a:p>
+        </p:txBody>
+      </p:sp>
+      <p:sp>
+        <p:nvSpPr>
+          <p:cNvPr id="8" name="Tekstfelt 7">
+            <a:extLst>
+              <a:ext uri="{FF2B5EF4-FFF2-40B4-BE49-F238E27FC236}">
+                <a16:creationId xmlns:a16="http://schemas.microsoft.com/office/drawing/2014/main" id="{2020A43D-B769-26F2-99DF-69BE5BD6AC82}"/>
+              </a:ext>
+            </a:extLst>
+          </p:cNvPr>
+          <p:cNvSpPr txBox="1"/>
+          <p:nvPr/>
+        </p:nvSpPr>
+        <p:spPr>
+          <a:xfrm>
+            <a:off x="588963" y="2050990"/>
+            <a:ext cx="3114635" cy="738664"/>
+          </a:xfrm>
+          <a:prstGeom prst="rect">
+            <a:avLst/>
+          </a:prstGeom>
+        </p:spPr>
+        <p:txBody>
+          <a:bodyPr vert="horz" wrap="none" lIns="0" tIns="0" rIns="0" bIns="0" rtlCol="0" anchor="t" anchorCtr="0">
+            <a:spAutoFit/>
+          </a:bodyPr>
+          <a:lstStyle/>
+          <a:p>
+            <a:pPr marL="0" marR="0" indent="0" algn="l" defTabSz="914400" rtl="0" eaLnBrk="1" fontAlgn="auto" latinLnBrk="0" hangingPunct="1">
+              <a:lnSpc>
+                <a:spcPct val="100000"/>
+              </a:lnSpc>
+              <a:spcBef>
+                <a:spcPct val="0"/>
+              </a:spcBef>
+              <a:spcAft>
+                <a:spcPts val="0"/>
+              </a:spcAft>
+              <a:buClrTx/>
+              <a:buSzTx/>
+              <a:buFontTx/>
+              <a:buNone/>
+              <a:tabLst/>
+            </a:pPr>
+            <a:r>
+              <a:rPr lang="da-DK" sz="2400" dirty="0" err="1"/>
+              <a:t>Captures</a:t>
+            </a:r>
+            <a:r>
+              <a:rPr lang="da-DK" sz="2400" dirty="0"/>
+              <a:t> regimes </a:t>
+            </a:r>
+            <a:r>
+              <a:rPr lang="da-DK" sz="2400" dirty="0" err="1"/>
+              <a:t>fairly</a:t>
+            </a:r>
+            <a:endParaRPr lang="da-DK" sz="2400" dirty="0"/>
+          </a:p>
+          <a:p>
+            <a:pPr marL="0" marR="0" indent="0" algn="l" defTabSz="914400" rtl="0" eaLnBrk="1" fontAlgn="auto" latinLnBrk="0" hangingPunct="1">
+              <a:lnSpc>
+                <a:spcPct val="100000"/>
+              </a:lnSpc>
+              <a:spcBef>
+                <a:spcPct val="0"/>
+              </a:spcBef>
+              <a:spcAft>
+                <a:spcPts val="0"/>
+              </a:spcAft>
+              <a:buClrTx/>
+              <a:buSzTx/>
+              <a:buFontTx/>
+              <a:buNone/>
+              <a:tabLst/>
+            </a:pPr>
+            <a:r>
+              <a:rPr lang="da-DK" sz="2400" b="0" dirty="0" err="1">
+                <a:solidFill>
+                  <a:schemeClr val="tx1"/>
+                </a:solidFill>
+                <a:latin typeface="+mn-lt"/>
+              </a:rPr>
+              <a:t>well</a:t>
+            </a:r>
+            <a:endParaRPr lang="da-DK" sz="2400" b="0" dirty="0">
+              <a:solidFill>
+                <a:schemeClr val="tx1"/>
+              </a:solidFill>
+              <a:latin typeface="+mn-lt"/>
+            </a:endParaRPr>
+          </a:p>
+        </p:txBody>
+      </p:sp>
+    </p:spTree>
+    <p:extLst>
+      <p:ext uri="{BB962C8B-B14F-4D97-AF65-F5344CB8AC3E}">
+        <p14:creationId xmlns:p14="http://schemas.microsoft.com/office/powerpoint/2010/main" val="3275911887"/>
+      </p:ext>
+    </p:extLst>
+  </p:cSld>
+  <p:clrMapOvr>
+    <a:masterClrMapping/>
+  </p:clrMapOvr>
+</p:sld>
+</file>
+
+<file path=ppt/slides/slide11.xml><?xml version="1.0" encoding="utf-8"?>
+<p:sld xmlns:a="http://schemas.openxmlformats.org/drawingml/2006/main" xmlns:r="http://schemas.openxmlformats.org/officeDocument/2006/relationships" xmlns:p="http://schemas.openxmlformats.org/presentationml/2006/main">
+  <p:cSld>
+    <p:spTree>
+      <p:nvGrpSpPr>
+        <p:cNvPr id="1" name=""/>
+        <p:cNvGrpSpPr/>
+        <p:nvPr/>
+      </p:nvGrpSpPr>
+      <p:grpSpPr>
+        <a:xfrm>
+          <a:off x="0" y="0"/>
+          <a:ext cx="0" cy="0"/>
+          <a:chOff x="0" y="0"/>
+          <a:chExt cx="0" cy="0"/>
+        </a:xfrm>
+      </p:grpSpPr>
+      <p:sp>
+        <p:nvSpPr>
+          <p:cNvPr id="2" name="Titel 1">
+            <a:extLst>
+              <a:ext uri="{FF2B5EF4-FFF2-40B4-BE49-F238E27FC236}">
+                <a16:creationId xmlns:a16="http://schemas.microsoft.com/office/drawing/2014/main" id="{3EB4BB56-3248-0E5D-CFE5-3B2E9C728CBE}"/>
+              </a:ext>
+            </a:extLst>
+          </p:cNvPr>
+          <p:cNvSpPr>
+            <a:spLocks noGrp="1"/>
+          </p:cNvSpPr>
+          <p:nvPr>
+            <p:ph type="title"/>
+          </p:nvPr>
+        </p:nvSpPr>
+        <p:spPr/>
+        <p:txBody>
+          <a:bodyPr/>
+          <a:lstStyle/>
+          <a:p>
+            <a:r>
+              <a:rPr lang="da-DK" dirty="0" err="1"/>
+              <a:t>Results</a:t>
+            </a:r>
+            <a:r>
+              <a:rPr lang="da-DK" dirty="0"/>
+              <a:t> 1/2</a:t>
+            </a:r>
+          </a:p>
+        </p:txBody>
+      </p:sp>
+      <p:pic>
+        <p:nvPicPr>
+          <p:cNvPr id="7" name="Pladsholder til indhold 6">
+            <a:extLst>
+              <a:ext uri="{FF2B5EF4-FFF2-40B4-BE49-F238E27FC236}">
+                <a16:creationId xmlns:a16="http://schemas.microsoft.com/office/drawing/2014/main" id="{6684F02A-81A1-67BB-23E8-F02BBBC4858D}"/>
+              </a:ext>
+            </a:extLst>
+          </p:cNvPr>
+          <p:cNvPicPr>
+            <a:picLocks noGrp="1" noChangeAspect="1"/>
+          </p:cNvPicPr>
+          <p:nvPr>
+            <p:ph idx="1"/>
+          </p:nvPr>
+        </p:nvPicPr>
+        <p:blipFill>
+          <a:blip r:embed="rId2"/>
+          <a:stretch>
+            <a:fillRect/>
+          </a:stretch>
+        </p:blipFill>
+        <p:spPr>
+          <a:xfrm>
+            <a:off x="241387" y="1245030"/>
+            <a:ext cx="11012487" cy="2443670"/>
+          </a:xfrm>
+          <a:prstGeom prst="rect">
+            <a:avLst/>
+          </a:prstGeom>
+        </p:spPr>
+      </p:pic>
+      <p:sp>
+        <p:nvSpPr>
+          <p:cNvPr id="4" name="Pladsholder til dato 3">
+            <a:extLst>
+              <a:ext uri="{FF2B5EF4-FFF2-40B4-BE49-F238E27FC236}">
+                <a16:creationId xmlns:a16="http://schemas.microsoft.com/office/drawing/2014/main" id="{25BB8457-63DF-8623-0BD4-89BC1AFE51D5}"/>
+              </a:ext>
+            </a:extLst>
+          </p:cNvPr>
+          <p:cNvSpPr>
+            <a:spLocks noGrp="1"/>
+          </p:cNvSpPr>
+          <p:nvPr>
+            <p:ph type="dt" sz="half" idx="10"/>
+          </p:nvPr>
+        </p:nvSpPr>
+        <p:spPr/>
+        <p:txBody>
+          <a:bodyPr/>
+          <a:lstStyle/>
+          <a:p>
+            <a:fld id="{A40A2488-620E-4717-952D-4163044243D3}" type="datetime1">
+              <a:rPr lang="da-DK" smtClean="0"/>
+              <a:t>25-04-2026</a:t>
+            </a:fld>
+            <a:endParaRPr lang="da-DK" dirty="0"/>
+          </a:p>
+        </p:txBody>
+      </p:sp>
+      <p:sp>
+        <p:nvSpPr>
+          <p:cNvPr id="5" name="Pladsholder til slidenummer 4">
+            <a:extLst>
+              <a:ext uri="{FF2B5EF4-FFF2-40B4-BE49-F238E27FC236}">
+                <a16:creationId xmlns:a16="http://schemas.microsoft.com/office/drawing/2014/main" id="{63210C95-CAF8-A6F6-8EB5-F4E6515E5E86}"/>
+              </a:ext>
+            </a:extLst>
+          </p:cNvPr>
+          <p:cNvSpPr>
+            <a:spLocks noGrp="1"/>
+          </p:cNvSpPr>
+          <p:nvPr>
+            <p:ph type="sldNum" sz="quarter" idx="12"/>
+          </p:nvPr>
+        </p:nvSpPr>
+        <p:spPr/>
+        <p:txBody>
+          <a:bodyPr/>
+          <a:lstStyle/>
+          <a:p>
+            <a:fld id="{091A926C-488A-4E3E-9C21-57CAA120E114}" type="slidenum">
+              <a:rPr lang="da-DK" smtClean="0"/>
+              <a:t>11</a:t>
+            </a:fld>
+            <a:endParaRPr lang="da-DK" dirty="0"/>
+          </a:p>
+        </p:txBody>
+      </p:sp>
+      <p:sp>
+        <p:nvSpPr>
+          <p:cNvPr id="9" name="Tekstfelt 8">
+            <a:extLst>
+              <a:ext uri="{FF2B5EF4-FFF2-40B4-BE49-F238E27FC236}">
+                <a16:creationId xmlns:a16="http://schemas.microsoft.com/office/drawing/2014/main" id="{7F0D2B07-6808-3402-FC0A-714D9F3427B3}"/>
+              </a:ext>
+            </a:extLst>
+          </p:cNvPr>
+          <p:cNvSpPr txBox="1"/>
+          <p:nvPr/>
+        </p:nvSpPr>
+        <p:spPr>
+          <a:xfrm>
+            <a:off x="3048712" y="3246470"/>
+            <a:ext cx="6097424" cy="369332"/>
+          </a:xfrm>
+          <a:prstGeom prst="rect">
+            <a:avLst/>
+          </a:prstGeom>
+          <a:noFill/>
+        </p:spPr>
+        <p:txBody>
+          <a:bodyPr wrap="square">
+            <a:spAutoFit/>
+          </a:bodyPr>
+          <a:lstStyle/>
+          <a:p>
+            <a:endParaRPr lang="da-DK" dirty="0"/>
+          </a:p>
+        </p:txBody>
+      </p:sp>
+      <p:pic>
+        <p:nvPicPr>
+          <p:cNvPr id="11" name="Billede 10">
+            <a:extLst>
+              <a:ext uri="{FF2B5EF4-FFF2-40B4-BE49-F238E27FC236}">
+                <a16:creationId xmlns:a16="http://schemas.microsoft.com/office/drawing/2014/main" id="{F3F2ECDD-CBB2-B57B-C272-2A71B688D882}"/>
+              </a:ext>
+            </a:extLst>
+          </p:cNvPr>
+          <p:cNvPicPr>
+            <a:picLocks noChangeAspect="1"/>
+          </p:cNvPicPr>
+          <p:nvPr/>
+        </p:nvPicPr>
+        <p:blipFill>
+          <a:blip r:embed="rId3"/>
+          <a:stretch>
+            <a:fillRect/>
+          </a:stretch>
+        </p:blipFill>
+        <p:spPr>
+          <a:xfrm>
+            <a:off x="307648" y="4054108"/>
+            <a:ext cx="11012487" cy="2639158"/>
+          </a:xfrm>
+          <a:prstGeom prst="rect">
+            <a:avLst/>
+          </a:prstGeom>
+        </p:spPr>
+      </p:pic>
+    </p:spTree>
+    <p:extLst>
+      <p:ext uri="{BB962C8B-B14F-4D97-AF65-F5344CB8AC3E}">
+        <p14:creationId xmlns:p14="http://schemas.microsoft.com/office/powerpoint/2010/main" val="1054710714"/>
+      </p:ext>
+    </p:extLst>
+  </p:cSld>
+  <p:clrMapOvr>
+    <a:masterClrMapping/>
+  </p:clrMapOvr>
+</p:sld>
+</file>
+
+<file path=ppt/slides/slide12.xml><?xml version="1.0" encoding="utf-8"?>
+<p:sld xmlns:a="http://schemas.openxmlformats.org/drawingml/2006/main" xmlns:r="http://schemas.openxmlformats.org/officeDocument/2006/relationships" xmlns:p="http://schemas.openxmlformats.org/presentationml/2006/main">
+  <p:cSld>
+    <p:spTree>
+      <p:nvGrpSpPr>
+        <p:cNvPr id="1" name=""/>
+        <p:cNvGrpSpPr/>
+        <p:nvPr/>
+      </p:nvGrpSpPr>
+      <p:grpSpPr>
+        <a:xfrm>
+          <a:off x="0" y="0"/>
+          <a:ext cx="0" cy="0"/>
+          <a:chOff x="0" y="0"/>
+          <a:chExt cx="0" cy="0"/>
+        </a:xfrm>
+      </p:grpSpPr>
+      <p:sp>
+        <p:nvSpPr>
+          <p:cNvPr id="2" name="Titel 1">
+            <a:extLst>
+              <a:ext uri="{FF2B5EF4-FFF2-40B4-BE49-F238E27FC236}">
+                <a16:creationId xmlns:a16="http://schemas.microsoft.com/office/drawing/2014/main" id="{58B67C44-B3D6-6C36-9DA0-DAB731BE9F14}"/>
+              </a:ext>
+            </a:extLst>
+          </p:cNvPr>
+          <p:cNvSpPr>
+            <a:spLocks noGrp="1"/>
+          </p:cNvSpPr>
+          <p:nvPr>
+            <p:ph type="title"/>
+          </p:nvPr>
+        </p:nvSpPr>
+        <p:spPr/>
+        <p:txBody>
+          <a:bodyPr/>
+          <a:lstStyle/>
+          <a:p>
+            <a:r>
+              <a:rPr lang="da-DK" dirty="0" err="1"/>
+              <a:t>Results</a:t>
+            </a:r>
+            <a:r>
+              <a:rPr lang="da-DK" dirty="0"/>
+              <a:t> 2/2</a:t>
+            </a:r>
+          </a:p>
+        </p:txBody>
+      </p:sp>
+      <p:pic>
+        <p:nvPicPr>
+          <p:cNvPr id="7" name="Pladsholder til indhold 6">
+            <a:extLst>
+              <a:ext uri="{FF2B5EF4-FFF2-40B4-BE49-F238E27FC236}">
+                <a16:creationId xmlns:a16="http://schemas.microsoft.com/office/drawing/2014/main" id="{0DF1FDA6-756A-BF6E-C5FE-F5F80B91309C}"/>
+              </a:ext>
+            </a:extLst>
+          </p:cNvPr>
+          <p:cNvPicPr>
+            <a:picLocks noGrp="1" noChangeAspect="1"/>
+          </p:cNvPicPr>
+          <p:nvPr>
+            <p:ph idx="1"/>
+          </p:nvPr>
+        </p:nvPicPr>
+        <p:blipFill>
+          <a:blip r:embed="rId2"/>
+          <a:stretch>
+            <a:fillRect/>
+          </a:stretch>
+        </p:blipFill>
+        <p:spPr>
+          <a:xfrm>
+            <a:off x="588963" y="2120937"/>
+            <a:ext cx="11012487" cy="3689275"/>
+          </a:xfrm>
+          <a:prstGeom prst="rect">
+            <a:avLst/>
+          </a:prstGeom>
+        </p:spPr>
+      </p:pic>
+      <p:sp>
+        <p:nvSpPr>
+          <p:cNvPr id="4" name="Pladsholder til dato 3">
+            <a:extLst>
+              <a:ext uri="{FF2B5EF4-FFF2-40B4-BE49-F238E27FC236}">
+                <a16:creationId xmlns:a16="http://schemas.microsoft.com/office/drawing/2014/main" id="{B05297C1-B46F-75BD-C23A-FD235CFB19C8}"/>
+              </a:ext>
+            </a:extLst>
+          </p:cNvPr>
+          <p:cNvSpPr>
+            <a:spLocks noGrp="1"/>
+          </p:cNvSpPr>
+          <p:nvPr>
+            <p:ph type="dt" sz="half" idx="10"/>
+          </p:nvPr>
+        </p:nvSpPr>
+        <p:spPr/>
+        <p:txBody>
+          <a:bodyPr/>
+          <a:lstStyle/>
+          <a:p>
+            <a:fld id="{A40A2488-620E-4717-952D-4163044243D3}" type="datetime1">
+              <a:rPr lang="da-DK" smtClean="0"/>
+              <a:t>25-04-2026</a:t>
+            </a:fld>
+            <a:endParaRPr lang="da-DK" dirty="0"/>
+          </a:p>
+        </p:txBody>
+      </p:sp>
+      <p:sp>
+        <p:nvSpPr>
+          <p:cNvPr id="5" name="Pladsholder til slidenummer 4">
+            <a:extLst>
+              <a:ext uri="{FF2B5EF4-FFF2-40B4-BE49-F238E27FC236}">
+                <a16:creationId xmlns:a16="http://schemas.microsoft.com/office/drawing/2014/main" id="{50E40463-E193-44C8-CEDC-F122CC8A7BDF}"/>
+              </a:ext>
+            </a:extLst>
+          </p:cNvPr>
+          <p:cNvSpPr>
+            <a:spLocks noGrp="1"/>
+          </p:cNvSpPr>
+          <p:nvPr>
+            <p:ph type="sldNum" sz="quarter" idx="12"/>
+          </p:nvPr>
+        </p:nvSpPr>
+        <p:spPr/>
+        <p:txBody>
+          <a:bodyPr/>
+          <a:lstStyle/>
+          <a:p>
+            <a:fld id="{091A926C-488A-4E3E-9C21-57CAA120E114}" type="slidenum">
+              <a:rPr lang="da-DK" smtClean="0"/>
+              <a:t>12</a:t>
+            </a:fld>
+            <a:endParaRPr lang="da-DK" dirty="0"/>
+          </a:p>
+        </p:txBody>
+      </p:sp>
+    </p:spTree>
+    <p:extLst>
+      <p:ext uri="{BB962C8B-B14F-4D97-AF65-F5344CB8AC3E}">
+        <p14:creationId xmlns:p14="http://schemas.microsoft.com/office/powerpoint/2010/main" val="3992317647"/>
+      </p:ext>
+    </p:extLst>
+  </p:cSld>
+  <p:clrMapOvr>
+    <a:masterClrMapping/>
+  </p:clrMapOvr>
+</p:sld>
+</file>
+
 <file path=ppt/slides/slide2.xml><?xml version="1.0" encoding="utf-8"?>
 <p:sld xmlns:a="http://schemas.openxmlformats.org/drawingml/2006/main" xmlns:r="http://schemas.openxmlformats.org/officeDocument/2006/relationships" xmlns:p="http://schemas.openxmlformats.org/presentationml/2006/main">
   <p:cSld>
@@ -16186,7 +16805,12 @@
             <p:ph idx="1"/>
           </p:nvPr>
         </p:nvSpPr>
-        <p:spPr/>
+        <p:spPr>
+          <a:xfrm>
+            <a:off x="588962" y="1261306"/>
+            <a:ext cx="11012488" cy="4673600"/>
+          </a:xfrm>
+        </p:spPr>
         <p:txBody>
           <a:bodyPr/>
           <a:lstStyle/>
@@ -16206,8 +16830,96 @@
           </a:p>
           <a:p>
             <a:r>
+              <a:rPr lang="da-DK" dirty="0"/>
+              <a:t>Assets </a:t>
+            </a:r>
+            <a:r>
               <a:rPr lang="da-DK" dirty="0" err="1"/>
-              <a:t>Includes</a:t>
+              <a:t>used</a:t>
+            </a:r>
+            <a:endParaRPr lang="da-DK" dirty="0"/>
+          </a:p>
+          <a:p>
+            <a:pPr lvl="1"/>
+            <a:r>
+              <a:rPr lang="da-DK" dirty="0"/>
+              <a:t>SP500</a:t>
+            </a:r>
+          </a:p>
+          <a:p>
+            <a:pPr lvl="1"/>
+            <a:r>
+              <a:rPr lang="da-DK" dirty="0"/>
+              <a:t>QQQ</a:t>
+            </a:r>
+          </a:p>
+          <a:p>
+            <a:pPr lvl="1"/>
+            <a:r>
+              <a:rPr lang="da-DK" dirty="0"/>
+              <a:t>Gold</a:t>
+            </a:r>
+          </a:p>
+          <a:p>
+            <a:pPr lvl="1"/>
+            <a:r>
+              <a:rPr lang="da-DK" dirty="0"/>
+              <a:t>RealEstate</a:t>
+            </a:r>
+          </a:p>
+          <a:p>
+            <a:r>
+              <a:rPr lang="da-DK" dirty="0"/>
+              <a:t>Features </a:t>
+            </a:r>
+            <a:r>
+              <a:rPr lang="da-DK" dirty="0" err="1"/>
+              <a:t>used</a:t>
+            </a:r>
+            <a:r>
+              <a:rPr lang="da-DK" dirty="0"/>
+              <a:t>.</a:t>
+            </a:r>
+          </a:p>
+          <a:p>
+            <a:pPr lvl="1"/>
+            <a:r>
+              <a:rPr lang="da-DK" dirty="0"/>
+              <a:t>Inflation </a:t>
+            </a:r>
+            <a:r>
+              <a:rPr lang="da-DK" dirty="0" err="1"/>
+              <a:t>change</a:t>
+            </a:r>
+            <a:r>
+              <a:rPr lang="da-DK" dirty="0"/>
+              <a:t> from t-1 -&gt; t</a:t>
+            </a:r>
+          </a:p>
+          <a:p>
+            <a:pPr lvl="1"/>
+            <a:r>
+              <a:rPr lang="da-DK" dirty="0"/>
+              <a:t>Oil return 12 </a:t>
+            </a:r>
+            <a:r>
+              <a:rPr lang="da-DK" dirty="0" err="1"/>
+              <a:t>month</a:t>
+            </a:r>
+            <a:r>
+              <a:rPr lang="da-DK" dirty="0"/>
+              <a:t> rolling standard deviation.</a:t>
+            </a:r>
+          </a:p>
+          <a:p>
+            <a:pPr lvl="1"/>
+            <a:r>
+              <a:rPr lang="da-DK" dirty="0"/>
+              <a:t>SP500 3, 6, and 12 </a:t>
+            </a:r>
+            <a:r>
+              <a:rPr lang="da-DK" dirty="0" err="1"/>
+              <a:t>month</a:t>
             </a:r>
             <a:r>
               <a:rPr lang="da-DK" dirty="0"/>
@@ -16215,26 +16927,57 @@
             </a:r>
             <a:r>
               <a:rPr lang="da-DK" dirty="0" err="1"/>
-              <a:t>macro</a:t>
-            </a:r>
-            <a:r>
-              <a:rPr lang="da-DK" dirty="0"/>
-              <a:t> variables, and </a:t>
+              <a:t>price</a:t>
+            </a:r>
+            <a:r>
+              <a:rPr lang="da-DK" dirty="0"/>
+              <a:t> momentum</a:t>
+            </a:r>
+          </a:p>
+          <a:p>
+            <a:pPr lvl="1"/>
+            <a:r>
+              <a:rPr lang="da-DK" dirty="0"/>
+              <a:t>SP500 3 and 6 </a:t>
             </a:r>
             <a:r>
               <a:rPr lang="da-DK" dirty="0" err="1"/>
-              <a:t>market</a:t>
-            </a:r>
-            <a:r>
-              <a:rPr lang="da-DK" dirty="0"/>
-              <a:t> data.</a:t>
-            </a:r>
+              <a:t>month</a:t>
+            </a:r>
+            <a:r>
+              <a:rPr lang="da-DK" dirty="0"/>
+              <a:t> </a:t>
+            </a:r>
+            <a:r>
+              <a:rPr lang="da-DK" dirty="0" err="1"/>
+              <a:t>volatility</a:t>
+            </a:r>
+            <a:endParaRPr lang="da-DK" dirty="0"/>
           </a:p>
           <a:p>
             <a:pPr lvl="1"/>
             <a:r>
-              <a:rPr lang="da-DK"/>
-              <a:t>Inflation, </a:t>
+              <a:rPr lang="da-DK" dirty="0"/>
+              <a:t>Credit </a:t>
+            </a:r>
+            <a:r>
+              <a:rPr lang="da-DK" dirty="0" err="1"/>
+              <a:t>spread</a:t>
+            </a:r>
+            <a:r>
+              <a:rPr lang="da-DK" dirty="0"/>
+              <a:t>, </a:t>
+            </a:r>
+            <a:r>
+              <a:rPr lang="en-US" dirty="0"/>
+              <a:t>diff in high-yield and investment bond prices</a:t>
+            </a:r>
+          </a:p>
+          <a:p>
+            <a:pPr lvl="1"/>
+            <a:r>
+              <a:rPr lang="en-US" dirty="0"/>
+              <a:t>Month-over-month change in credit spread</a:t>
             </a:r>
             <a:endParaRPr lang="da-DK" dirty="0"/>
           </a:p>
@@ -16302,6 +17045,1734 @@
     <p:extLst>
       <p:ext uri="{BB962C8B-B14F-4D97-AF65-F5344CB8AC3E}">
         <p14:creationId xmlns:p14="http://schemas.microsoft.com/office/powerpoint/2010/main" val="281564843"/>
+      </p:ext>
+    </p:extLst>
+  </p:cSld>
+  <p:clrMapOvr>
+    <a:masterClrMapping/>
+  </p:clrMapOvr>
+</p:sld>
+</file>
+
+<file path=ppt/slides/slide4.xml><?xml version="1.0" encoding="utf-8"?>
+<p:sld xmlns:a="http://schemas.openxmlformats.org/drawingml/2006/main" xmlns:r="http://schemas.openxmlformats.org/officeDocument/2006/relationships" xmlns:p="http://schemas.openxmlformats.org/presentationml/2006/main">
+  <p:cSld>
+    <p:spTree>
+      <p:nvGrpSpPr>
+        <p:cNvPr id="1" name=""/>
+        <p:cNvGrpSpPr/>
+        <p:nvPr/>
+      </p:nvGrpSpPr>
+      <p:grpSpPr>
+        <a:xfrm>
+          <a:off x="0" y="0"/>
+          <a:ext cx="0" cy="0"/>
+          <a:chOff x="0" y="0"/>
+          <a:chExt cx="0" cy="0"/>
+        </a:xfrm>
+      </p:grpSpPr>
+      <p:sp>
+        <p:nvSpPr>
+          <p:cNvPr id="2" name="Titel 1">
+            <a:extLst>
+              <a:ext uri="{FF2B5EF4-FFF2-40B4-BE49-F238E27FC236}">
+                <a16:creationId xmlns:a16="http://schemas.microsoft.com/office/drawing/2014/main" id="{50DDAB3C-5B64-DA92-3B44-F181280DECEA}"/>
+              </a:ext>
+            </a:extLst>
+          </p:cNvPr>
+          <p:cNvSpPr>
+            <a:spLocks noGrp="1"/>
+          </p:cNvSpPr>
+          <p:nvPr>
+            <p:ph type="title"/>
+          </p:nvPr>
+        </p:nvSpPr>
+        <p:spPr/>
+        <p:txBody>
+          <a:bodyPr/>
+          <a:lstStyle/>
+          <a:p>
+            <a:r>
+              <a:rPr lang="da-DK" dirty="0"/>
+              <a:t>Assets for </a:t>
+            </a:r>
+            <a:r>
+              <a:rPr lang="da-DK" dirty="0" err="1"/>
+              <a:t>different</a:t>
+            </a:r>
+            <a:r>
+              <a:rPr lang="da-DK" dirty="0"/>
+              <a:t> regimes</a:t>
+            </a:r>
+          </a:p>
+        </p:txBody>
+      </p:sp>
+      <p:sp>
+        <p:nvSpPr>
+          <p:cNvPr id="4" name="Pladsholder til dato 3">
+            <a:extLst>
+              <a:ext uri="{FF2B5EF4-FFF2-40B4-BE49-F238E27FC236}">
+                <a16:creationId xmlns:a16="http://schemas.microsoft.com/office/drawing/2014/main" id="{81A37C90-13EB-5416-BFA1-20A123291A9A}"/>
+              </a:ext>
+            </a:extLst>
+          </p:cNvPr>
+          <p:cNvSpPr>
+            <a:spLocks noGrp="1"/>
+          </p:cNvSpPr>
+          <p:nvPr>
+            <p:ph type="dt" sz="half" idx="10"/>
+          </p:nvPr>
+        </p:nvSpPr>
+        <p:spPr/>
+        <p:txBody>
+          <a:bodyPr/>
+          <a:lstStyle/>
+          <a:p>
+            <a:fld id="{A40A2488-620E-4717-952D-4163044243D3}" type="datetime1">
+              <a:rPr lang="da-DK" smtClean="0"/>
+              <a:t>25-04-2026</a:t>
+            </a:fld>
+            <a:endParaRPr lang="da-DK" dirty="0"/>
+          </a:p>
+        </p:txBody>
+      </p:sp>
+      <p:sp>
+        <p:nvSpPr>
+          <p:cNvPr id="5" name="Pladsholder til slidenummer 4">
+            <a:extLst>
+              <a:ext uri="{FF2B5EF4-FFF2-40B4-BE49-F238E27FC236}">
+                <a16:creationId xmlns:a16="http://schemas.microsoft.com/office/drawing/2014/main" id="{5C33423A-14F3-EAE5-2B98-287D03D299A8}"/>
+              </a:ext>
+            </a:extLst>
+          </p:cNvPr>
+          <p:cNvSpPr>
+            <a:spLocks noGrp="1"/>
+          </p:cNvSpPr>
+          <p:nvPr>
+            <p:ph type="sldNum" sz="quarter" idx="12"/>
+          </p:nvPr>
+        </p:nvSpPr>
+        <p:spPr/>
+        <p:txBody>
+          <a:bodyPr/>
+          <a:lstStyle/>
+          <a:p>
+            <a:fld id="{091A926C-488A-4E3E-9C21-57CAA120E114}" type="slidenum">
+              <a:rPr lang="da-DK" smtClean="0"/>
+              <a:t>4</a:t>
+            </a:fld>
+            <a:endParaRPr lang="da-DK" dirty="0"/>
+          </a:p>
+        </p:txBody>
+      </p:sp>
+      <p:sp>
+        <p:nvSpPr>
+          <p:cNvPr id="9" name="Tekstfelt 8">
+            <a:extLst>
+              <a:ext uri="{FF2B5EF4-FFF2-40B4-BE49-F238E27FC236}">
+                <a16:creationId xmlns:a16="http://schemas.microsoft.com/office/drawing/2014/main" id="{81469FC3-27D6-A8D9-D530-ACBC5FDDE78C}"/>
+              </a:ext>
+            </a:extLst>
+          </p:cNvPr>
+          <p:cNvSpPr txBox="1"/>
+          <p:nvPr/>
+        </p:nvSpPr>
+        <p:spPr>
+          <a:xfrm>
+            <a:off x="3048712" y="3246470"/>
+            <a:ext cx="6097424" cy="369332"/>
+          </a:xfrm>
+          <a:prstGeom prst="rect">
+            <a:avLst/>
+          </a:prstGeom>
+          <a:noFill/>
+        </p:spPr>
+        <p:txBody>
+          <a:bodyPr wrap="square">
+            <a:spAutoFit/>
+          </a:bodyPr>
+          <a:lstStyle/>
+          <a:p>
+            <a:endParaRPr lang="da-DK" dirty="0"/>
+          </a:p>
+        </p:txBody>
+      </p:sp>
+      <p:sp>
+        <p:nvSpPr>
+          <p:cNvPr id="13" name="Pladsholder til indhold 12">
+            <a:extLst>
+              <a:ext uri="{FF2B5EF4-FFF2-40B4-BE49-F238E27FC236}">
+                <a16:creationId xmlns:a16="http://schemas.microsoft.com/office/drawing/2014/main" id="{11590E9F-0AB1-A589-4C44-AFD5CF1C08CD}"/>
+              </a:ext>
+            </a:extLst>
+          </p:cNvPr>
+          <p:cNvSpPr>
+            <a:spLocks noGrp="1"/>
+          </p:cNvSpPr>
+          <p:nvPr>
+            <p:ph idx="1"/>
+          </p:nvPr>
+        </p:nvSpPr>
+        <p:spPr>
+          <a:xfrm>
+            <a:off x="223919" y="1724790"/>
+            <a:ext cx="5316802" cy="2381748"/>
+          </a:xfrm>
+        </p:spPr>
+        <p:txBody>
+          <a:bodyPr/>
+          <a:lstStyle/>
+          <a:p>
+            <a:r>
+              <a:rPr lang="da-DK" dirty="0"/>
+              <a:t>Equity assets </a:t>
+            </a:r>
+            <a:r>
+              <a:rPr lang="da-DK" dirty="0" err="1"/>
+              <a:t>are</a:t>
+            </a:r>
+            <a:r>
+              <a:rPr lang="da-DK" dirty="0"/>
+              <a:t> </a:t>
+            </a:r>
+            <a:r>
+              <a:rPr lang="da-DK" dirty="0" err="1"/>
+              <a:t>seems</a:t>
+            </a:r>
+            <a:r>
+              <a:rPr lang="da-DK" dirty="0"/>
+              <a:t> </a:t>
+            </a:r>
+            <a:r>
+              <a:rPr lang="da-DK" dirty="0" err="1"/>
+              <a:t>strongly</a:t>
+            </a:r>
+            <a:br>
+              <a:rPr lang="da-DK" dirty="0"/>
+            </a:br>
+            <a:r>
+              <a:rPr lang="da-DK" dirty="0" err="1"/>
+              <a:t>positivetly</a:t>
+            </a:r>
+            <a:r>
+              <a:rPr lang="da-DK" dirty="0"/>
+              <a:t> </a:t>
+            </a:r>
+            <a:r>
+              <a:rPr lang="da-DK" dirty="0" err="1"/>
+              <a:t>correlatet</a:t>
+            </a:r>
+            <a:endParaRPr lang="da-DK" dirty="0"/>
+          </a:p>
+          <a:p>
+            <a:r>
+              <a:rPr lang="da-DK" dirty="0"/>
+              <a:t>Switch </a:t>
+            </a:r>
+            <a:r>
+              <a:rPr lang="da-DK" dirty="0" err="1"/>
+              <a:t>into</a:t>
+            </a:r>
+            <a:r>
+              <a:rPr lang="da-DK" dirty="0"/>
+              <a:t> gold, in </a:t>
+            </a:r>
+            <a:r>
+              <a:rPr lang="da-DK" dirty="0" err="1"/>
+              <a:t>uncertainty</a:t>
+            </a:r>
+            <a:r>
+              <a:rPr lang="da-DK" dirty="0"/>
+              <a:t> </a:t>
+            </a:r>
+          </a:p>
+          <a:p>
+            <a:endParaRPr lang="da-DK" dirty="0"/>
+          </a:p>
+          <a:p>
+            <a:endParaRPr lang="da-DK" dirty="0"/>
+          </a:p>
+        </p:txBody>
+      </p:sp>
+      <p:sp>
+        <p:nvSpPr>
+          <p:cNvPr id="15" name="Tekstfelt 14">
+            <a:extLst>
+              <a:ext uri="{FF2B5EF4-FFF2-40B4-BE49-F238E27FC236}">
+                <a16:creationId xmlns:a16="http://schemas.microsoft.com/office/drawing/2014/main" id="{15AC3762-67A3-EAE9-18F2-7868CA9064EE}"/>
+              </a:ext>
+            </a:extLst>
+          </p:cNvPr>
+          <p:cNvSpPr txBox="1"/>
+          <p:nvPr/>
+        </p:nvSpPr>
+        <p:spPr>
+          <a:xfrm>
+            <a:off x="3048712" y="3246470"/>
+            <a:ext cx="6097424" cy="369332"/>
+          </a:xfrm>
+          <a:prstGeom prst="rect">
+            <a:avLst/>
+          </a:prstGeom>
+          <a:noFill/>
+        </p:spPr>
+        <p:txBody>
+          <a:bodyPr wrap="square">
+            <a:spAutoFit/>
+          </a:bodyPr>
+          <a:lstStyle/>
+          <a:p>
+            <a:endParaRPr lang="da-DK" dirty="0"/>
+          </a:p>
+        </p:txBody>
+      </p:sp>
+      <p:pic>
+        <p:nvPicPr>
+          <p:cNvPr id="19" name="Billede 18">
+            <a:extLst>
+              <a:ext uri="{FF2B5EF4-FFF2-40B4-BE49-F238E27FC236}">
+                <a16:creationId xmlns:a16="http://schemas.microsoft.com/office/drawing/2014/main" id="{085F4913-EE36-D1D3-DB9E-B8D089B126C5}"/>
+              </a:ext>
+            </a:extLst>
+          </p:cNvPr>
+          <p:cNvPicPr>
+            <a:picLocks noChangeAspect="1"/>
+          </p:cNvPicPr>
+          <p:nvPr/>
+        </p:nvPicPr>
+        <p:blipFill>
+          <a:blip r:embed="rId2"/>
+          <a:stretch>
+            <a:fillRect/>
+          </a:stretch>
+        </p:blipFill>
+        <p:spPr>
+          <a:xfrm>
+            <a:off x="5188404" y="1158352"/>
+            <a:ext cx="6648450" cy="4914900"/>
+          </a:xfrm>
+          <a:prstGeom prst="rect">
+            <a:avLst/>
+          </a:prstGeom>
+        </p:spPr>
+      </p:pic>
+    </p:spTree>
+    <p:extLst>
+      <p:ext uri="{BB962C8B-B14F-4D97-AF65-F5344CB8AC3E}">
+        <p14:creationId xmlns:p14="http://schemas.microsoft.com/office/powerpoint/2010/main" val="88466975"/>
+      </p:ext>
+    </p:extLst>
+  </p:cSld>
+  <p:clrMapOvr>
+    <a:masterClrMapping/>
+  </p:clrMapOvr>
+</p:sld>
+</file>
+
+<file path=ppt/slides/slide5.xml><?xml version="1.0" encoding="utf-8"?>
+<p:sld xmlns:a="http://schemas.openxmlformats.org/drawingml/2006/main" xmlns:r="http://schemas.openxmlformats.org/officeDocument/2006/relationships" xmlns:p="http://schemas.openxmlformats.org/presentationml/2006/main">
+  <p:cSld>
+    <p:spTree>
+      <p:nvGrpSpPr>
+        <p:cNvPr id="1" name=""/>
+        <p:cNvGrpSpPr/>
+        <p:nvPr/>
+      </p:nvGrpSpPr>
+      <p:grpSpPr>
+        <a:xfrm>
+          <a:off x="0" y="0"/>
+          <a:ext cx="0" cy="0"/>
+          <a:chOff x="0" y="0"/>
+          <a:chExt cx="0" cy="0"/>
+        </a:xfrm>
+      </p:grpSpPr>
+      <p:sp>
+        <p:nvSpPr>
+          <p:cNvPr id="2" name="Titel 1">
+            <a:extLst>
+              <a:ext uri="{FF2B5EF4-FFF2-40B4-BE49-F238E27FC236}">
+                <a16:creationId xmlns:a16="http://schemas.microsoft.com/office/drawing/2014/main" id="{4540D4B1-9972-1158-F107-B69784579C68}"/>
+              </a:ext>
+            </a:extLst>
+          </p:cNvPr>
+          <p:cNvSpPr>
+            <a:spLocks noGrp="1"/>
+          </p:cNvSpPr>
+          <p:nvPr>
+            <p:ph type="title"/>
+          </p:nvPr>
+        </p:nvSpPr>
+        <p:spPr/>
+        <p:txBody>
+          <a:bodyPr/>
+          <a:lstStyle/>
+          <a:p>
+            <a:r>
+              <a:rPr lang="da-DK" dirty="0"/>
+              <a:t>Transition </a:t>
+            </a:r>
+            <a:r>
+              <a:rPr lang="da-DK" dirty="0" err="1"/>
+              <a:t>probablities</a:t>
+            </a:r>
+            <a:endParaRPr lang="da-DK" dirty="0"/>
+          </a:p>
+        </p:txBody>
+      </p:sp>
+      <p:sp>
+        <p:nvSpPr>
+          <p:cNvPr id="4" name="Pladsholder til dato 3">
+            <a:extLst>
+              <a:ext uri="{FF2B5EF4-FFF2-40B4-BE49-F238E27FC236}">
+                <a16:creationId xmlns:a16="http://schemas.microsoft.com/office/drawing/2014/main" id="{1B5063E9-9E59-B2F4-6004-F4DE7C295D40}"/>
+              </a:ext>
+            </a:extLst>
+          </p:cNvPr>
+          <p:cNvSpPr>
+            <a:spLocks noGrp="1"/>
+          </p:cNvSpPr>
+          <p:nvPr>
+            <p:ph type="dt" sz="half" idx="10"/>
+          </p:nvPr>
+        </p:nvSpPr>
+        <p:spPr/>
+        <p:txBody>
+          <a:bodyPr/>
+          <a:lstStyle/>
+          <a:p>
+            <a:fld id="{A40A2488-620E-4717-952D-4163044243D3}" type="datetime1">
+              <a:rPr lang="da-DK" smtClean="0"/>
+              <a:t>25-04-2026</a:t>
+            </a:fld>
+            <a:endParaRPr lang="da-DK" dirty="0"/>
+          </a:p>
+        </p:txBody>
+      </p:sp>
+      <p:sp>
+        <p:nvSpPr>
+          <p:cNvPr id="5" name="Pladsholder til slidenummer 4">
+            <a:extLst>
+              <a:ext uri="{FF2B5EF4-FFF2-40B4-BE49-F238E27FC236}">
+                <a16:creationId xmlns:a16="http://schemas.microsoft.com/office/drawing/2014/main" id="{69661C18-A3C1-E9FF-04BE-1AFE2485F5A8}"/>
+              </a:ext>
+            </a:extLst>
+          </p:cNvPr>
+          <p:cNvSpPr>
+            <a:spLocks noGrp="1"/>
+          </p:cNvSpPr>
+          <p:nvPr>
+            <p:ph type="sldNum" sz="quarter" idx="12"/>
+          </p:nvPr>
+        </p:nvSpPr>
+        <p:spPr/>
+        <p:txBody>
+          <a:bodyPr/>
+          <a:lstStyle/>
+          <a:p>
+            <a:fld id="{091A926C-488A-4E3E-9C21-57CAA120E114}" type="slidenum">
+              <a:rPr lang="da-DK" smtClean="0"/>
+              <a:t>5</a:t>
+            </a:fld>
+            <a:endParaRPr lang="da-DK" dirty="0"/>
+          </a:p>
+        </p:txBody>
+      </p:sp>
+      <p:sp>
+        <p:nvSpPr>
+          <p:cNvPr id="9" name="Tekstfelt 8">
+            <a:extLst>
+              <a:ext uri="{FF2B5EF4-FFF2-40B4-BE49-F238E27FC236}">
+                <a16:creationId xmlns:a16="http://schemas.microsoft.com/office/drawing/2014/main" id="{72EE4E1D-F369-C103-B6EB-491FC1971CA4}"/>
+              </a:ext>
+            </a:extLst>
+          </p:cNvPr>
+          <p:cNvSpPr txBox="1"/>
+          <p:nvPr/>
+        </p:nvSpPr>
+        <p:spPr>
+          <a:xfrm>
+            <a:off x="775530" y="2198777"/>
+            <a:ext cx="3471729" cy="1200329"/>
+          </a:xfrm>
+          <a:prstGeom prst="rect">
+            <a:avLst/>
+          </a:prstGeom>
+          <a:noFill/>
+        </p:spPr>
+        <p:txBody>
+          <a:bodyPr wrap="square">
+            <a:spAutoFit/>
+          </a:bodyPr>
+          <a:lstStyle/>
+          <a:p>
+            <a:pPr marL="285750" indent="-285750">
+              <a:buFont typeface="Arial" panose="020B0604020202020204" pitchFamily="34" charset="0"/>
+              <a:buChar char="•"/>
+            </a:pPr>
+            <a:r>
+              <a:rPr lang="da-DK" dirty="0"/>
+              <a:t>Transition </a:t>
+            </a:r>
+            <a:r>
+              <a:rPr lang="da-DK" dirty="0" err="1"/>
+              <a:t>probablities</a:t>
+            </a:r>
+            <a:endParaRPr lang="da-DK" dirty="0"/>
+          </a:p>
+          <a:p>
+            <a:pPr marL="285750" indent="-285750">
+              <a:buFont typeface="Arial" panose="020B0604020202020204" pitchFamily="34" charset="0"/>
+              <a:buChar char="•"/>
+            </a:pPr>
+            <a:r>
+              <a:rPr lang="da-DK" dirty="0"/>
+              <a:t>Tells </a:t>
+            </a:r>
+            <a:r>
+              <a:rPr lang="da-DK" dirty="0" err="1"/>
+              <a:t>us</a:t>
+            </a:r>
+            <a:r>
+              <a:rPr lang="da-DK" dirty="0"/>
+              <a:t> </a:t>
+            </a:r>
+            <a:r>
+              <a:rPr lang="da-DK" dirty="0" err="1"/>
+              <a:t>alot</a:t>
+            </a:r>
+            <a:r>
+              <a:rPr lang="da-DK" dirty="0"/>
+              <a:t> </a:t>
+            </a:r>
+            <a:r>
+              <a:rPr lang="da-DK" dirty="0" err="1"/>
+              <a:t>about</a:t>
+            </a:r>
+            <a:r>
+              <a:rPr lang="da-DK" dirty="0"/>
+              <a:t> </a:t>
+            </a:r>
+            <a:r>
+              <a:rPr lang="da-DK" dirty="0" err="1"/>
+              <a:t>how</a:t>
+            </a:r>
+            <a:r>
+              <a:rPr lang="da-DK" dirty="0"/>
+              <a:t> to </a:t>
+            </a:r>
+            <a:r>
+              <a:rPr lang="da-DK" dirty="0" err="1"/>
+              <a:t>which</a:t>
+            </a:r>
+            <a:r>
+              <a:rPr lang="da-DK" dirty="0"/>
+              <a:t> assets to </a:t>
+            </a:r>
+            <a:r>
+              <a:rPr lang="da-DK" dirty="0" err="1"/>
+              <a:t>allocate</a:t>
+            </a:r>
+            <a:r>
+              <a:rPr lang="da-DK" dirty="0"/>
+              <a:t> </a:t>
+            </a:r>
+            <a:r>
+              <a:rPr lang="da-DK" dirty="0" err="1"/>
+              <a:t>liqiudity</a:t>
+            </a:r>
+            <a:r>
+              <a:rPr lang="da-DK" dirty="0"/>
+              <a:t>.</a:t>
+            </a:r>
+          </a:p>
+        </p:txBody>
+      </p:sp>
+      <p:sp>
+        <p:nvSpPr>
+          <p:cNvPr id="11" name="Pladsholder til indhold 10">
+            <a:extLst>
+              <a:ext uri="{FF2B5EF4-FFF2-40B4-BE49-F238E27FC236}">
+                <a16:creationId xmlns:a16="http://schemas.microsoft.com/office/drawing/2014/main" id="{9E3A9974-AB50-3445-88BB-4755752A9433}"/>
+              </a:ext>
+            </a:extLst>
+          </p:cNvPr>
+          <p:cNvSpPr>
+            <a:spLocks noGrp="1"/>
+          </p:cNvSpPr>
+          <p:nvPr>
+            <p:ph idx="1"/>
+          </p:nvPr>
+        </p:nvSpPr>
+        <p:spPr>
+          <a:xfrm>
+            <a:off x="272769" y="5713665"/>
+            <a:ext cx="11012488" cy="4673600"/>
+          </a:xfrm>
+        </p:spPr>
+        <p:txBody>
+          <a:bodyPr/>
+          <a:lstStyle/>
+          <a:p>
+            <a:endParaRPr lang="da-DK" dirty="0"/>
+          </a:p>
+        </p:txBody>
+      </p:sp>
+      <p:pic>
+        <p:nvPicPr>
+          <p:cNvPr id="13" name="Billede 12">
+            <a:extLst>
+              <a:ext uri="{FF2B5EF4-FFF2-40B4-BE49-F238E27FC236}">
+                <a16:creationId xmlns:a16="http://schemas.microsoft.com/office/drawing/2014/main" id="{F5B804DB-0AFA-4AE5-7008-774DE69CA979}"/>
+              </a:ext>
+            </a:extLst>
+          </p:cNvPr>
+          <p:cNvPicPr>
+            <a:picLocks noChangeAspect="1"/>
+          </p:cNvPicPr>
+          <p:nvPr/>
+        </p:nvPicPr>
+        <p:blipFill>
+          <a:blip r:embed="rId2"/>
+          <a:stretch>
+            <a:fillRect/>
+          </a:stretch>
+        </p:blipFill>
+        <p:spPr>
+          <a:xfrm>
+            <a:off x="6164599" y="1859377"/>
+            <a:ext cx="4572000" cy="3724275"/>
+          </a:xfrm>
+          <a:prstGeom prst="rect">
+            <a:avLst/>
+          </a:prstGeom>
+        </p:spPr>
+      </p:pic>
+    </p:spTree>
+    <p:extLst>
+      <p:ext uri="{BB962C8B-B14F-4D97-AF65-F5344CB8AC3E}">
+        <p14:creationId xmlns:p14="http://schemas.microsoft.com/office/powerpoint/2010/main" val="2035015298"/>
+      </p:ext>
+    </p:extLst>
+  </p:cSld>
+  <p:clrMapOvr>
+    <a:masterClrMapping/>
+  </p:clrMapOvr>
+</p:sld>
+</file>
+
+<file path=ppt/slides/slide6.xml><?xml version="1.0" encoding="utf-8"?>
+<p:sld xmlns:a="http://schemas.openxmlformats.org/drawingml/2006/main" xmlns:r="http://schemas.openxmlformats.org/officeDocument/2006/relationships" xmlns:p="http://schemas.openxmlformats.org/presentationml/2006/main">
+  <p:cSld>
+    <p:spTree>
+      <p:nvGrpSpPr>
+        <p:cNvPr id="1" name=""/>
+        <p:cNvGrpSpPr/>
+        <p:nvPr/>
+      </p:nvGrpSpPr>
+      <p:grpSpPr>
+        <a:xfrm>
+          <a:off x="0" y="0"/>
+          <a:ext cx="0" cy="0"/>
+          <a:chOff x="0" y="0"/>
+          <a:chExt cx="0" cy="0"/>
+        </a:xfrm>
+      </p:grpSpPr>
+      <p:sp>
+        <p:nvSpPr>
+          <p:cNvPr id="2" name="Titel 1">
+            <a:extLst>
+              <a:ext uri="{FF2B5EF4-FFF2-40B4-BE49-F238E27FC236}">
+                <a16:creationId xmlns:a16="http://schemas.microsoft.com/office/drawing/2014/main" id="{196275E3-D639-764D-3FB9-8D4FDD29ED7C}"/>
+              </a:ext>
+            </a:extLst>
+          </p:cNvPr>
+          <p:cNvSpPr>
+            <a:spLocks noGrp="1"/>
+          </p:cNvSpPr>
+          <p:nvPr>
+            <p:ph type="title"/>
+          </p:nvPr>
+        </p:nvSpPr>
+        <p:spPr/>
+        <p:txBody>
+          <a:bodyPr/>
+          <a:lstStyle/>
+          <a:p>
+            <a:r>
+              <a:rPr lang="da-DK" dirty="0"/>
+              <a:t>Trading </a:t>
+            </a:r>
+            <a:r>
+              <a:rPr lang="da-DK" dirty="0" err="1"/>
+              <a:t>strategy</a:t>
+            </a:r>
+            <a:r>
+              <a:rPr lang="da-DK" dirty="0"/>
+              <a:t> and </a:t>
+            </a:r>
+            <a:r>
+              <a:rPr lang="da-DK" dirty="0" err="1"/>
+              <a:t>backtesting</a:t>
+            </a:r>
+            <a:endParaRPr lang="da-DK" dirty="0"/>
+          </a:p>
+        </p:txBody>
+      </p:sp>
+      <p:sp>
+        <p:nvSpPr>
+          <p:cNvPr id="3" name="Pladsholder til indhold 2">
+            <a:extLst>
+              <a:ext uri="{FF2B5EF4-FFF2-40B4-BE49-F238E27FC236}">
+                <a16:creationId xmlns:a16="http://schemas.microsoft.com/office/drawing/2014/main" id="{FC49E5C0-1957-422C-B54A-2768E395F92E}"/>
+              </a:ext>
+            </a:extLst>
+          </p:cNvPr>
+          <p:cNvSpPr>
+            <a:spLocks noGrp="1"/>
+          </p:cNvSpPr>
+          <p:nvPr>
+            <p:ph idx="1"/>
+          </p:nvPr>
+        </p:nvSpPr>
+        <p:spPr/>
+        <p:txBody>
+          <a:bodyPr/>
+          <a:lstStyle/>
+          <a:p>
+            <a:r>
+              <a:rPr lang="da-DK" dirty="0"/>
+              <a:t>In sample </a:t>
+            </a:r>
+            <a:r>
+              <a:rPr lang="da-DK" dirty="0" err="1"/>
+              <a:t>backtesting</a:t>
+            </a:r>
+            <a:r>
+              <a:rPr lang="da-DK" dirty="0"/>
+              <a:t> from, 2009-2026</a:t>
+            </a:r>
+          </a:p>
+          <a:p>
+            <a:r>
+              <a:rPr lang="da-DK" dirty="0" err="1"/>
+              <a:t>Use</a:t>
+            </a:r>
+            <a:r>
+              <a:rPr lang="da-DK" dirty="0"/>
+              <a:t> all data up till time = t-1 to cluster data in </a:t>
+            </a:r>
+            <a:r>
+              <a:rPr lang="da-DK" dirty="0" err="1"/>
+              <a:t>each</a:t>
+            </a:r>
+            <a:r>
+              <a:rPr lang="da-DK" dirty="0"/>
+              <a:t> regime</a:t>
+            </a:r>
+          </a:p>
+          <a:p>
+            <a:r>
+              <a:rPr lang="da-DK" dirty="0"/>
+              <a:t>For </a:t>
+            </a:r>
+            <a:r>
+              <a:rPr lang="da-DK" dirty="0" err="1"/>
+              <a:t>each</a:t>
+            </a:r>
+            <a:r>
+              <a:rPr lang="da-DK" dirty="0"/>
+              <a:t> regime </a:t>
+            </a:r>
+            <a:r>
+              <a:rPr lang="da-DK" dirty="0" err="1"/>
+              <a:t>calculate</a:t>
+            </a:r>
+            <a:r>
+              <a:rPr lang="da-DK" dirty="0"/>
+              <a:t> </a:t>
+            </a:r>
+            <a:r>
+              <a:rPr lang="da-DK" dirty="0" err="1"/>
+              <a:t>markowitz</a:t>
+            </a:r>
+            <a:r>
+              <a:rPr lang="da-DK" dirty="0"/>
+              <a:t> </a:t>
+            </a:r>
+            <a:r>
+              <a:rPr lang="da-DK" dirty="0" err="1"/>
+              <a:t>weights</a:t>
+            </a:r>
+            <a:r>
+              <a:rPr lang="da-DK" dirty="0"/>
+              <a:t>.</a:t>
+            </a:r>
+          </a:p>
+          <a:p>
+            <a:r>
+              <a:rPr lang="da-DK" dirty="0"/>
+              <a:t>For observation t, </a:t>
+            </a:r>
+            <a:r>
+              <a:rPr lang="da-DK" dirty="0" err="1"/>
+              <a:t>calculate</a:t>
+            </a:r>
+            <a:r>
+              <a:rPr lang="da-DK" dirty="0"/>
+              <a:t> distance to nearest cluster, with KNN find </a:t>
+            </a:r>
+            <a:br>
+              <a:rPr lang="da-DK" dirty="0"/>
+            </a:br>
+            <a:r>
+              <a:rPr lang="da-DK" dirty="0" err="1"/>
+              <a:t>similar</a:t>
+            </a:r>
+            <a:r>
+              <a:rPr lang="da-DK" dirty="0"/>
+              <a:t> situations and look at </a:t>
+            </a:r>
+            <a:r>
+              <a:rPr lang="da-DK" dirty="0" err="1"/>
+              <a:t>those</a:t>
+            </a:r>
+            <a:r>
+              <a:rPr lang="da-DK" dirty="0"/>
+              <a:t> </a:t>
+            </a:r>
+            <a:r>
+              <a:rPr lang="da-DK" dirty="0" err="1"/>
+              <a:t>outcomes</a:t>
+            </a:r>
+            <a:r>
+              <a:rPr lang="da-DK" dirty="0"/>
+              <a:t>, </a:t>
+            </a:r>
+            <a:r>
+              <a:rPr lang="da-DK" dirty="0" err="1"/>
+              <a:t>what</a:t>
+            </a:r>
+            <a:r>
+              <a:rPr lang="da-DK" dirty="0"/>
+              <a:t> is </a:t>
+            </a:r>
+            <a:r>
+              <a:rPr lang="da-DK" dirty="0" err="1"/>
+              <a:t>our</a:t>
+            </a:r>
+            <a:r>
+              <a:rPr lang="da-DK" dirty="0"/>
+              <a:t> transition matrix.</a:t>
+            </a:r>
+          </a:p>
+          <a:p>
+            <a:r>
+              <a:rPr lang="da-DK" dirty="0"/>
+              <a:t>Bland </a:t>
+            </a:r>
+            <a:r>
+              <a:rPr lang="da-DK" dirty="0" err="1"/>
+              <a:t>weights</a:t>
+            </a:r>
+            <a:r>
+              <a:rPr lang="da-DK" dirty="0"/>
+              <a:t> so </a:t>
+            </a:r>
+            <a:r>
+              <a:rPr lang="da-DK" dirty="0" err="1"/>
+              <a:t>if</a:t>
+            </a:r>
+            <a:r>
+              <a:rPr lang="da-DK" dirty="0"/>
+              <a:t> </a:t>
+            </a:r>
+            <a:r>
+              <a:rPr lang="da-DK" dirty="0" err="1"/>
+              <a:t>they</a:t>
+            </a:r>
+            <a:r>
+              <a:rPr lang="da-DK" dirty="0"/>
+              <a:t> </a:t>
+            </a:r>
+            <a:r>
+              <a:rPr lang="da-DK" dirty="0" err="1"/>
+              <a:t>are</a:t>
+            </a:r>
+            <a:r>
+              <a:rPr lang="da-DK" dirty="0"/>
+              <a:t> </a:t>
+            </a:r>
+            <a:r>
+              <a:rPr lang="da-DK" dirty="0" err="1"/>
+              <a:t>weighted</a:t>
+            </a:r>
+            <a:r>
+              <a:rPr lang="da-DK" dirty="0"/>
+              <a:t> by </a:t>
+            </a:r>
+            <a:r>
+              <a:rPr lang="da-DK" dirty="0" err="1"/>
+              <a:t>probability</a:t>
+            </a:r>
+            <a:r>
+              <a:rPr lang="da-DK" dirty="0"/>
+              <a:t> of </a:t>
+            </a:r>
+            <a:r>
+              <a:rPr lang="da-DK" dirty="0" err="1"/>
+              <a:t>which</a:t>
+            </a:r>
+            <a:r>
+              <a:rPr lang="da-DK" dirty="0"/>
+              <a:t> regime the </a:t>
+            </a:r>
+            <a:r>
+              <a:rPr lang="da-DK" dirty="0" err="1"/>
+              <a:t>next</a:t>
+            </a:r>
+            <a:r>
+              <a:rPr lang="da-DK" dirty="0"/>
+              <a:t> </a:t>
+            </a:r>
+            <a:r>
+              <a:rPr lang="da-DK" dirty="0" err="1"/>
+              <a:t>one</a:t>
+            </a:r>
+            <a:r>
+              <a:rPr lang="da-DK" dirty="0"/>
+              <a:t> </a:t>
+            </a:r>
+            <a:r>
+              <a:rPr lang="da-DK" dirty="0" err="1"/>
+              <a:t>are</a:t>
+            </a:r>
+            <a:r>
+              <a:rPr lang="da-DK" dirty="0"/>
+              <a:t>.</a:t>
+            </a:r>
+          </a:p>
+        </p:txBody>
+      </p:sp>
+      <p:sp>
+        <p:nvSpPr>
+          <p:cNvPr id="4" name="Pladsholder til dato 3">
+            <a:extLst>
+              <a:ext uri="{FF2B5EF4-FFF2-40B4-BE49-F238E27FC236}">
+                <a16:creationId xmlns:a16="http://schemas.microsoft.com/office/drawing/2014/main" id="{14797E31-D6DF-ADB2-02CE-122BA1B60629}"/>
+              </a:ext>
+            </a:extLst>
+          </p:cNvPr>
+          <p:cNvSpPr>
+            <a:spLocks noGrp="1"/>
+          </p:cNvSpPr>
+          <p:nvPr>
+            <p:ph type="dt" sz="half" idx="10"/>
+          </p:nvPr>
+        </p:nvSpPr>
+        <p:spPr/>
+        <p:txBody>
+          <a:bodyPr/>
+          <a:lstStyle/>
+          <a:p>
+            <a:fld id="{A40A2488-620E-4717-952D-4163044243D3}" type="datetime1">
+              <a:rPr lang="da-DK" smtClean="0"/>
+              <a:t>25-04-2026</a:t>
+            </a:fld>
+            <a:endParaRPr lang="da-DK" dirty="0"/>
+          </a:p>
+        </p:txBody>
+      </p:sp>
+      <p:sp>
+        <p:nvSpPr>
+          <p:cNvPr id="5" name="Pladsholder til slidenummer 4">
+            <a:extLst>
+              <a:ext uri="{FF2B5EF4-FFF2-40B4-BE49-F238E27FC236}">
+                <a16:creationId xmlns:a16="http://schemas.microsoft.com/office/drawing/2014/main" id="{C0950B4F-C9D9-9165-AC3D-429D4AF0C816}"/>
+              </a:ext>
+            </a:extLst>
+          </p:cNvPr>
+          <p:cNvSpPr>
+            <a:spLocks noGrp="1"/>
+          </p:cNvSpPr>
+          <p:nvPr>
+            <p:ph type="sldNum" sz="quarter" idx="12"/>
+          </p:nvPr>
+        </p:nvSpPr>
+        <p:spPr/>
+        <p:txBody>
+          <a:bodyPr/>
+          <a:lstStyle/>
+          <a:p>
+            <a:fld id="{091A926C-488A-4E3E-9C21-57CAA120E114}" type="slidenum">
+              <a:rPr lang="da-DK" smtClean="0"/>
+              <a:t>6</a:t>
+            </a:fld>
+            <a:endParaRPr lang="da-DK" dirty="0"/>
+          </a:p>
+        </p:txBody>
+      </p:sp>
+    </p:spTree>
+    <p:extLst>
+      <p:ext uri="{BB962C8B-B14F-4D97-AF65-F5344CB8AC3E}">
+        <p14:creationId xmlns:p14="http://schemas.microsoft.com/office/powerpoint/2010/main" val="84247530"/>
+      </p:ext>
+    </p:extLst>
+  </p:cSld>
+  <p:clrMapOvr>
+    <a:masterClrMapping/>
+  </p:clrMapOvr>
+</p:sld>
+</file>
+
+<file path=ppt/slides/slide7.xml><?xml version="1.0" encoding="utf-8"?>
+<p:sld xmlns:a="http://schemas.openxmlformats.org/drawingml/2006/main" xmlns:r="http://schemas.openxmlformats.org/officeDocument/2006/relationships" xmlns:p="http://schemas.openxmlformats.org/presentationml/2006/main">
+  <p:cSld>
+    <p:spTree>
+      <p:nvGrpSpPr>
+        <p:cNvPr id="1" name=""/>
+        <p:cNvGrpSpPr/>
+        <p:nvPr/>
+      </p:nvGrpSpPr>
+      <p:grpSpPr>
+        <a:xfrm>
+          <a:off x="0" y="0"/>
+          <a:ext cx="0" cy="0"/>
+          <a:chOff x="0" y="0"/>
+          <a:chExt cx="0" cy="0"/>
+        </a:xfrm>
+      </p:grpSpPr>
+      <p:sp>
+        <p:nvSpPr>
+          <p:cNvPr id="2" name="Titel 1">
+            <a:extLst>
+              <a:ext uri="{FF2B5EF4-FFF2-40B4-BE49-F238E27FC236}">
+                <a16:creationId xmlns:a16="http://schemas.microsoft.com/office/drawing/2014/main" id="{CACAAB9C-C330-6C49-FD7D-814C3B6F2600}"/>
+              </a:ext>
+            </a:extLst>
+          </p:cNvPr>
+          <p:cNvSpPr>
+            <a:spLocks noGrp="1"/>
+          </p:cNvSpPr>
+          <p:nvPr>
+            <p:ph type="title"/>
+          </p:nvPr>
+        </p:nvSpPr>
+        <p:spPr/>
+        <p:txBody>
+          <a:bodyPr/>
+          <a:lstStyle/>
+          <a:p>
+            <a:r>
+              <a:rPr lang="da-DK" dirty="0"/>
+              <a:t>Full model diagram</a:t>
+            </a:r>
+          </a:p>
+        </p:txBody>
+      </p:sp>
+      <p:sp>
+        <p:nvSpPr>
+          <p:cNvPr id="4" name="Pladsholder til dato 3">
+            <a:extLst>
+              <a:ext uri="{FF2B5EF4-FFF2-40B4-BE49-F238E27FC236}">
+                <a16:creationId xmlns:a16="http://schemas.microsoft.com/office/drawing/2014/main" id="{5E8E1F1B-FD7E-A255-2F65-3BC7317E46C4}"/>
+              </a:ext>
+            </a:extLst>
+          </p:cNvPr>
+          <p:cNvSpPr>
+            <a:spLocks noGrp="1"/>
+          </p:cNvSpPr>
+          <p:nvPr>
+            <p:ph type="dt" sz="half" idx="10"/>
+          </p:nvPr>
+        </p:nvSpPr>
+        <p:spPr/>
+        <p:txBody>
+          <a:bodyPr/>
+          <a:lstStyle/>
+          <a:p>
+            <a:fld id="{A40A2488-620E-4717-952D-4163044243D3}" type="datetime1">
+              <a:rPr lang="da-DK" smtClean="0"/>
+              <a:t>25-04-2026</a:t>
+            </a:fld>
+            <a:endParaRPr lang="da-DK" dirty="0"/>
+          </a:p>
+        </p:txBody>
+      </p:sp>
+      <p:sp>
+        <p:nvSpPr>
+          <p:cNvPr id="5" name="Pladsholder til slidenummer 4">
+            <a:extLst>
+              <a:ext uri="{FF2B5EF4-FFF2-40B4-BE49-F238E27FC236}">
+                <a16:creationId xmlns:a16="http://schemas.microsoft.com/office/drawing/2014/main" id="{19B5402E-2EF9-FD5D-38CA-8BE04CA79C46}"/>
+              </a:ext>
+            </a:extLst>
+          </p:cNvPr>
+          <p:cNvSpPr>
+            <a:spLocks noGrp="1"/>
+          </p:cNvSpPr>
+          <p:nvPr>
+            <p:ph type="sldNum" sz="quarter" idx="12"/>
+          </p:nvPr>
+        </p:nvSpPr>
+        <p:spPr/>
+        <p:txBody>
+          <a:bodyPr/>
+          <a:lstStyle/>
+          <a:p>
+            <a:fld id="{091A926C-488A-4E3E-9C21-57CAA120E114}" type="slidenum">
+              <a:rPr lang="da-DK" smtClean="0"/>
+              <a:t>7</a:t>
+            </a:fld>
+            <a:endParaRPr lang="da-DK" dirty="0"/>
+          </a:p>
+        </p:txBody>
+      </p:sp>
+      <p:pic>
+        <p:nvPicPr>
+          <p:cNvPr id="10" name="Pladsholder til indhold 9">
+            <a:extLst>
+              <a:ext uri="{FF2B5EF4-FFF2-40B4-BE49-F238E27FC236}">
+                <a16:creationId xmlns:a16="http://schemas.microsoft.com/office/drawing/2014/main" id="{D81B4F7D-FDE7-D137-A201-BD38585BC7E2}"/>
+              </a:ext>
+            </a:extLst>
+          </p:cNvPr>
+          <p:cNvPicPr>
+            <a:picLocks noGrp="1" noChangeAspect="1"/>
+          </p:cNvPicPr>
+          <p:nvPr>
+            <p:ph idx="1"/>
+          </p:nvPr>
+        </p:nvPicPr>
+        <p:blipFill>
+          <a:blip r:embed="rId2"/>
+          <a:stretch>
+            <a:fillRect/>
+          </a:stretch>
+        </p:blipFill>
+        <p:spPr>
+          <a:xfrm>
+            <a:off x="375805" y="1563686"/>
+            <a:ext cx="10635496" cy="4673600"/>
+          </a:xfrm>
+          <a:prstGeom prst="rect">
+            <a:avLst/>
+          </a:prstGeom>
+        </p:spPr>
+      </p:pic>
+    </p:spTree>
+    <p:extLst>
+      <p:ext uri="{BB962C8B-B14F-4D97-AF65-F5344CB8AC3E}">
+        <p14:creationId xmlns:p14="http://schemas.microsoft.com/office/powerpoint/2010/main" val="1106279569"/>
+      </p:ext>
+    </p:extLst>
+  </p:cSld>
+  <p:clrMapOvr>
+    <a:masterClrMapping/>
+  </p:clrMapOvr>
+</p:sld>
+</file>
+
+<file path=ppt/slides/slide8.xml><?xml version="1.0" encoding="utf-8"?>
+<p:sld xmlns:a="http://schemas.openxmlformats.org/drawingml/2006/main" xmlns:r="http://schemas.openxmlformats.org/officeDocument/2006/relationships" xmlns:p="http://schemas.openxmlformats.org/presentationml/2006/main">
+  <p:cSld>
+    <p:spTree>
+      <p:nvGrpSpPr>
+        <p:cNvPr id="1" name=""/>
+        <p:cNvGrpSpPr/>
+        <p:nvPr/>
+      </p:nvGrpSpPr>
+      <p:grpSpPr>
+        <a:xfrm>
+          <a:off x="0" y="0"/>
+          <a:ext cx="0" cy="0"/>
+          <a:chOff x="0" y="0"/>
+          <a:chExt cx="0" cy="0"/>
+        </a:xfrm>
+      </p:grpSpPr>
+      <p:sp>
+        <p:nvSpPr>
+          <p:cNvPr id="2" name="Titel 1">
+            <a:extLst>
+              <a:ext uri="{FF2B5EF4-FFF2-40B4-BE49-F238E27FC236}">
+                <a16:creationId xmlns:a16="http://schemas.microsoft.com/office/drawing/2014/main" id="{D2FB18EA-3784-0640-C3CF-4C1F5D7586C4}"/>
+              </a:ext>
+            </a:extLst>
+          </p:cNvPr>
+          <p:cNvSpPr>
+            <a:spLocks noGrp="1"/>
+          </p:cNvSpPr>
+          <p:nvPr>
+            <p:ph type="title"/>
+          </p:nvPr>
+        </p:nvSpPr>
+        <p:spPr/>
+        <p:txBody>
+          <a:bodyPr/>
+          <a:lstStyle/>
+          <a:p>
+            <a:r>
+              <a:rPr lang="da-DK" dirty="0"/>
+              <a:t>From transition </a:t>
+            </a:r>
+            <a:r>
+              <a:rPr lang="da-DK" dirty="0" err="1"/>
+              <a:t>probablity</a:t>
+            </a:r>
+            <a:r>
+              <a:rPr lang="da-DK" dirty="0"/>
+              <a:t> and </a:t>
+            </a:r>
+            <a:r>
+              <a:rPr lang="da-DK" dirty="0" err="1"/>
+              <a:t>weight</a:t>
+            </a:r>
+            <a:r>
+              <a:rPr lang="da-DK" dirty="0"/>
+              <a:t> to </a:t>
+            </a:r>
+            <a:r>
+              <a:rPr lang="da-DK" dirty="0" err="1"/>
+              <a:t>portfolio</a:t>
+            </a:r>
+            <a:endParaRPr lang="da-DK" dirty="0"/>
+          </a:p>
+        </p:txBody>
+      </p:sp>
+      <p:sp>
+        <p:nvSpPr>
+          <p:cNvPr id="4" name="Pladsholder til dato 3">
+            <a:extLst>
+              <a:ext uri="{FF2B5EF4-FFF2-40B4-BE49-F238E27FC236}">
+                <a16:creationId xmlns:a16="http://schemas.microsoft.com/office/drawing/2014/main" id="{48A5C2B7-2BF2-9F75-D318-9A2307ED4AF4}"/>
+              </a:ext>
+            </a:extLst>
+          </p:cNvPr>
+          <p:cNvSpPr>
+            <a:spLocks noGrp="1"/>
+          </p:cNvSpPr>
+          <p:nvPr>
+            <p:ph type="dt" sz="half" idx="10"/>
+          </p:nvPr>
+        </p:nvSpPr>
+        <p:spPr/>
+        <p:txBody>
+          <a:bodyPr/>
+          <a:lstStyle/>
+          <a:p>
+            <a:fld id="{A40A2488-620E-4717-952D-4163044243D3}" type="datetime1">
+              <a:rPr lang="da-DK" smtClean="0"/>
+              <a:t>25-04-2026</a:t>
+            </a:fld>
+            <a:endParaRPr lang="da-DK" dirty="0"/>
+          </a:p>
+        </p:txBody>
+      </p:sp>
+      <p:sp>
+        <p:nvSpPr>
+          <p:cNvPr id="5" name="Pladsholder til slidenummer 4">
+            <a:extLst>
+              <a:ext uri="{FF2B5EF4-FFF2-40B4-BE49-F238E27FC236}">
+                <a16:creationId xmlns:a16="http://schemas.microsoft.com/office/drawing/2014/main" id="{FEC32D37-0DEF-1E30-2BB9-9F2CEDE3AEA1}"/>
+              </a:ext>
+            </a:extLst>
+          </p:cNvPr>
+          <p:cNvSpPr>
+            <a:spLocks noGrp="1"/>
+          </p:cNvSpPr>
+          <p:nvPr>
+            <p:ph type="sldNum" sz="quarter" idx="12"/>
+          </p:nvPr>
+        </p:nvSpPr>
+        <p:spPr/>
+        <p:txBody>
+          <a:bodyPr/>
+          <a:lstStyle/>
+          <a:p>
+            <a:fld id="{091A926C-488A-4E3E-9C21-57CAA120E114}" type="slidenum">
+              <a:rPr lang="da-DK" smtClean="0"/>
+              <a:t>8</a:t>
+            </a:fld>
+            <a:endParaRPr lang="da-DK" dirty="0"/>
+          </a:p>
+        </p:txBody>
+      </p:sp>
+      <p:sp>
+        <p:nvSpPr>
+          <p:cNvPr id="15" name="Tekstfelt 14">
+            <a:extLst>
+              <a:ext uri="{FF2B5EF4-FFF2-40B4-BE49-F238E27FC236}">
+                <a16:creationId xmlns:a16="http://schemas.microsoft.com/office/drawing/2014/main" id="{5C7E8502-8ACC-9AEB-D21D-C3A909650686}"/>
+              </a:ext>
+            </a:extLst>
+          </p:cNvPr>
+          <p:cNvSpPr txBox="1"/>
+          <p:nvPr/>
+        </p:nvSpPr>
+        <p:spPr>
+          <a:xfrm flipH="1">
+            <a:off x="414253" y="1484313"/>
+            <a:ext cx="5341058" cy="2215991"/>
+          </a:xfrm>
+          <a:prstGeom prst="rect">
+            <a:avLst/>
+          </a:prstGeom>
+        </p:spPr>
+        <p:txBody>
+          <a:bodyPr vert="horz" wrap="square" lIns="0" tIns="0" rIns="0" bIns="0" rtlCol="0" anchor="t" anchorCtr="0">
+            <a:spAutoFit/>
+          </a:bodyPr>
+          <a:lstStyle/>
+          <a:p>
+            <a:pPr marL="342900" marR="0" indent="-342900" algn="l" defTabSz="914400" rtl="0" eaLnBrk="1" fontAlgn="auto" latinLnBrk="0" hangingPunct="1">
+              <a:lnSpc>
+                <a:spcPct val="100000"/>
+              </a:lnSpc>
+              <a:spcBef>
+                <a:spcPct val="0"/>
+              </a:spcBef>
+              <a:spcAft>
+                <a:spcPts val="0"/>
+              </a:spcAft>
+              <a:buClrTx/>
+              <a:buSzTx/>
+              <a:buFont typeface="Arial" panose="020B0604020202020204" pitchFamily="34" charset="0"/>
+              <a:buChar char="•"/>
+              <a:tabLst/>
+            </a:pPr>
+            <a:r>
+              <a:rPr lang="da-DK" sz="2400" dirty="0"/>
+              <a:t>From </a:t>
+            </a:r>
+            <a:r>
+              <a:rPr lang="da-DK" sz="2400" dirty="0" err="1"/>
+              <a:t>table</a:t>
+            </a:r>
+            <a:r>
+              <a:rPr lang="da-DK" sz="2400" dirty="0"/>
+              <a:t> 2 </a:t>
+            </a:r>
+            <a:r>
+              <a:rPr lang="da-DK" sz="2400" dirty="0" err="1"/>
+              <a:t>multiply</a:t>
+            </a:r>
+            <a:r>
+              <a:rPr lang="da-DK" sz="2400" dirty="0"/>
+              <a:t> asset 1 </a:t>
+            </a:r>
+            <a:r>
+              <a:rPr lang="da-DK" sz="2400" dirty="0" err="1"/>
+              <a:t>weight</a:t>
+            </a:r>
+            <a:r>
+              <a:rPr lang="da-DK" sz="2400" dirty="0"/>
+              <a:t> in regime 1 by </a:t>
+            </a:r>
+            <a:r>
+              <a:rPr lang="da-DK" sz="2400" dirty="0" err="1"/>
+              <a:t>table</a:t>
+            </a:r>
+            <a:r>
+              <a:rPr lang="da-DK" sz="2400" dirty="0"/>
+              <a:t> 2 transition </a:t>
+            </a:r>
+            <a:r>
+              <a:rPr lang="da-DK" sz="2400" dirty="0" err="1"/>
+              <a:t>probablity</a:t>
+            </a:r>
+            <a:r>
+              <a:rPr lang="da-DK" sz="2400" dirty="0"/>
+              <a:t> in regime 1 in </a:t>
+            </a:r>
+            <a:r>
+              <a:rPr lang="da-DK" sz="2400" dirty="0" err="1"/>
+              <a:t>this</a:t>
+            </a:r>
+            <a:r>
+              <a:rPr lang="da-DK" sz="2400" dirty="0"/>
+              <a:t> </a:t>
+            </a:r>
+            <a:r>
+              <a:rPr lang="da-DK" sz="2400" dirty="0" err="1"/>
+              <a:t>example</a:t>
+            </a:r>
+            <a:r>
+              <a:rPr lang="da-DK" sz="2400" dirty="0"/>
+              <a:t> 0.1*0.2=0.02,</a:t>
+            </a:r>
+          </a:p>
+          <a:p>
+            <a:pPr marL="342900" marR="0" indent="-342900" algn="l" defTabSz="914400" rtl="0" eaLnBrk="1" fontAlgn="auto" latinLnBrk="0" hangingPunct="1">
+              <a:lnSpc>
+                <a:spcPct val="100000"/>
+              </a:lnSpc>
+              <a:spcBef>
+                <a:spcPct val="0"/>
+              </a:spcBef>
+              <a:spcAft>
+                <a:spcPts val="0"/>
+              </a:spcAft>
+              <a:buClrTx/>
+              <a:buSzTx/>
+              <a:buFont typeface="Arial" panose="020B0604020202020204" pitchFamily="34" charset="0"/>
+              <a:buChar char="•"/>
+              <a:tabLst/>
+            </a:pPr>
+            <a:r>
+              <a:rPr lang="da-DK" sz="2400" b="0" dirty="0">
+                <a:solidFill>
+                  <a:schemeClr val="tx1"/>
+                </a:solidFill>
+                <a:latin typeface="+mn-lt"/>
+              </a:rPr>
+              <a:t>Asset 1 </a:t>
+            </a:r>
+            <a:r>
+              <a:rPr lang="da-DK" sz="2400" b="0" dirty="0" err="1">
+                <a:solidFill>
+                  <a:schemeClr val="tx1"/>
+                </a:solidFill>
+                <a:latin typeface="+mn-lt"/>
+              </a:rPr>
+              <a:t>will</a:t>
+            </a:r>
+            <a:r>
+              <a:rPr lang="da-DK" sz="2400" b="0" dirty="0">
+                <a:solidFill>
+                  <a:schemeClr val="tx1"/>
+                </a:solidFill>
+                <a:latin typeface="+mn-lt"/>
+              </a:rPr>
+              <a:t> </a:t>
+            </a:r>
+            <a:r>
+              <a:rPr lang="da-DK" sz="2400" b="0" dirty="0" err="1">
+                <a:solidFill>
+                  <a:schemeClr val="tx1"/>
+                </a:solidFill>
+                <a:latin typeface="+mn-lt"/>
+              </a:rPr>
+              <a:t>be</a:t>
+            </a:r>
+            <a:r>
+              <a:rPr lang="da-DK" sz="2400" b="0" dirty="0">
+                <a:solidFill>
+                  <a:schemeClr val="tx1"/>
+                </a:solidFill>
+                <a:latin typeface="+mn-lt"/>
+              </a:rPr>
+              <a:t> </a:t>
+            </a:r>
+            <a:r>
+              <a:rPr lang="da-DK" sz="2400" b="0" dirty="0" err="1">
+                <a:solidFill>
+                  <a:schemeClr val="tx1"/>
+                </a:solidFill>
+                <a:latin typeface="+mn-lt"/>
+              </a:rPr>
+              <a:t>allocated</a:t>
+            </a:r>
+            <a:r>
+              <a:rPr lang="da-DK" sz="2400" b="0" dirty="0">
+                <a:solidFill>
+                  <a:schemeClr val="tx1"/>
+                </a:solidFill>
+                <a:latin typeface="+mn-lt"/>
+              </a:rPr>
+              <a:t> 2 procent in </a:t>
+            </a:r>
+            <a:r>
+              <a:rPr lang="da-DK" sz="2400" b="0" dirty="0" err="1">
+                <a:solidFill>
+                  <a:schemeClr val="tx1"/>
+                </a:solidFill>
+                <a:latin typeface="+mn-lt"/>
+              </a:rPr>
+              <a:t>this</a:t>
+            </a:r>
+            <a:r>
+              <a:rPr lang="da-DK" sz="2400" b="0" dirty="0">
+                <a:solidFill>
+                  <a:schemeClr val="tx1"/>
+                </a:solidFill>
+                <a:latin typeface="+mn-lt"/>
+              </a:rPr>
+              <a:t> scenario</a:t>
+            </a:r>
+          </a:p>
+        </p:txBody>
+      </p:sp>
+      <p:pic>
+        <p:nvPicPr>
+          <p:cNvPr id="19" name="Billede 18">
+            <a:extLst>
+              <a:ext uri="{FF2B5EF4-FFF2-40B4-BE49-F238E27FC236}">
+                <a16:creationId xmlns:a16="http://schemas.microsoft.com/office/drawing/2014/main" id="{8C47CFBA-B957-270F-D753-662D5A83DB14}"/>
+              </a:ext>
+            </a:extLst>
+          </p:cNvPr>
+          <p:cNvPicPr>
+            <a:picLocks noChangeAspect="1"/>
+          </p:cNvPicPr>
+          <p:nvPr/>
+        </p:nvPicPr>
+        <p:blipFill>
+          <a:blip r:embed="rId2"/>
+          <a:stretch>
+            <a:fillRect/>
+          </a:stretch>
+        </p:blipFill>
+        <p:spPr>
+          <a:xfrm>
+            <a:off x="4390929" y="3771857"/>
+            <a:ext cx="7515225" cy="2552700"/>
+          </a:xfrm>
+          <a:prstGeom prst="rect">
+            <a:avLst/>
+          </a:prstGeom>
+        </p:spPr>
+      </p:pic>
+      <p:sp>
+        <p:nvSpPr>
+          <p:cNvPr id="21" name="Pladsholder til indhold 20">
+            <a:extLst>
+              <a:ext uri="{FF2B5EF4-FFF2-40B4-BE49-F238E27FC236}">
+                <a16:creationId xmlns:a16="http://schemas.microsoft.com/office/drawing/2014/main" id="{DEB715BC-3DC3-28B7-9A3E-96FC85DC2379}"/>
+              </a:ext>
+            </a:extLst>
+          </p:cNvPr>
+          <p:cNvSpPr>
+            <a:spLocks noGrp="1"/>
+          </p:cNvSpPr>
+          <p:nvPr>
+            <p:ph idx="1"/>
+          </p:nvPr>
+        </p:nvSpPr>
+        <p:spPr>
+          <a:xfrm>
+            <a:off x="207203" y="6995974"/>
+            <a:ext cx="11012488" cy="4673600"/>
+          </a:xfrm>
+        </p:spPr>
+        <p:txBody>
+          <a:bodyPr/>
+          <a:lstStyle/>
+          <a:p>
+            <a:endParaRPr lang="da-DK" dirty="0"/>
+          </a:p>
+        </p:txBody>
+      </p:sp>
+      <p:pic>
+        <p:nvPicPr>
+          <p:cNvPr id="23" name="Billede 22">
+            <a:extLst>
+              <a:ext uri="{FF2B5EF4-FFF2-40B4-BE49-F238E27FC236}">
+                <a16:creationId xmlns:a16="http://schemas.microsoft.com/office/drawing/2014/main" id="{C37956F4-95C1-5583-3503-CEBD537B7017}"/>
+              </a:ext>
+            </a:extLst>
+          </p:cNvPr>
+          <p:cNvPicPr>
+            <a:picLocks noChangeAspect="1"/>
+          </p:cNvPicPr>
+          <p:nvPr/>
+        </p:nvPicPr>
+        <p:blipFill>
+          <a:blip r:embed="rId3"/>
+          <a:stretch>
+            <a:fillRect/>
+          </a:stretch>
+        </p:blipFill>
+        <p:spPr>
+          <a:xfrm>
+            <a:off x="6335371" y="1052513"/>
+            <a:ext cx="5172075" cy="2390775"/>
+          </a:xfrm>
+          <a:prstGeom prst="rect">
+            <a:avLst/>
+          </a:prstGeom>
+        </p:spPr>
+      </p:pic>
+    </p:spTree>
+    <p:extLst>
+      <p:ext uri="{BB962C8B-B14F-4D97-AF65-F5344CB8AC3E}">
+        <p14:creationId xmlns:p14="http://schemas.microsoft.com/office/powerpoint/2010/main" val="3102408885"/>
+      </p:ext>
+    </p:extLst>
+  </p:cSld>
+  <p:clrMapOvr>
+    <a:masterClrMapping/>
+  </p:clrMapOvr>
+</p:sld>
+</file>
+
+<file path=ppt/slides/slide9.xml><?xml version="1.0" encoding="utf-8"?>
+<p:sld xmlns:a="http://schemas.openxmlformats.org/drawingml/2006/main" xmlns:r="http://schemas.openxmlformats.org/officeDocument/2006/relationships" xmlns:p="http://schemas.openxmlformats.org/presentationml/2006/main">
+  <p:cSld>
+    <p:spTree>
+      <p:nvGrpSpPr>
+        <p:cNvPr id="1" name=""/>
+        <p:cNvGrpSpPr/>
+        <p:nvPr/>
+      </p:nvGrpSpPr>
+      <p:grpSpPr>
+        <a:xfrm>
+          <a:off x="0" y="0"/>
+          <a:ext cx="0" cy="0"/>
+          <a:chOff x="0" y="0"/>
+          <a:chExt cx="0" cy="0"/>
+        </a:xfrm>
+      </p:grpSpPr>
+      <p:sp>
+        <p:nvSpPr>
+          <p:cNvPr id="2" name="Titel 1">
+            <a:extLst>
+              <a:ext uri="{FF2B5EF4-FFF2-40B4-BE49-F238E27FC236}">
+                <a16:creationId xmlns:a16="http://schemas.microsoft.com/office/drawing/2014/main" id="{B451E42B-ADCE-C4DD-BDF6-12AD470310E6}"/>
+              </a:ext>
+            </a:extLst>
+          </p:cNvPr>
+          <p:cNvSpPr>
+            <a:spLocks noGrp="1"/>
+          </p:cNvSpPr>
+          <p:nvPr>
+            <p:ph type="title"/>
+          </p:nvPr>
+        </p:nvSpPr>
+        <p:spPr/>
+        <p:txBody>
+          <a:bodyPr/>
+          <a:lstStyle/>
+          <a:p>
+            <a:r>
+              <a:rPr lang="da-DK" dirty="0"/>
+              <a:t>K-Means 1/2 </a:t>
+            </a:r>
+          </a:p>
+        </p:txBody>
+      </p:sp>
+      <p:pic>
+        <p:nvPicPr>
+          <p:cNvPr id="7" name="Pladsholder til indhold 6">
+            <a:extLst>
+              <a:ext uri="{FF2B5EF4-FFF2-40B4-BE49-F238E27FC236}">
+                <a16:creationId xmlns:a16="http://schemas.microsoft.com/office/drawing/2014/main" id="{F63410F5-6CF2-3C1E-A187-42FC4FE2AD98}"/>
+              </a:ext>
+            </a:extLst>
+          </p:cNvPr>
+          <p:cNvPicPr>
+            <a:picLocks noGrp="1" noChangeAspect="1"/>
+          </p:cNvPicPr>
+          <p:nvPr>
+            <p:ph idx="1"/>
+          </p:nvPr>
+        </p:nvPicPr>
+        <p:blipFill>
+          <a:blip r:embed="rId2"/>
+          <a:stretch>
+            <a:fillRect/>
+          </a:stretch>
+        </p:blipFill>
+        <p:spPr>
+          <a:xfrm>
+            <a:off x="117304" y="2068082"/>
+            <a:ext cx="5818576" cy="3751952"/>
+          </a:xfrm>
+          <a:prstGeom prst="rect">
+            <a:avLst/>
+          </a:prstGeom>
+        </p:spPr>
+      </p:pic>
+      <p:sp>
+        <p:nvSpPr>
+          <p:cNvPr id="4" name="Pladsholder til dato 3">
+            <a:extLst>
+              <a:ext uri="{FF2B5EF4-FFF2-40B4-BE49-F238E27FC236}">
+                <a16:creationId xmlns:a16="http://schemas.microsoft.com/office/drawing/2014/main" id="{8D997EAF-988D-EF49-9CF7-7F2B6FE4D6C6}"/>
+              </a:ext>
+            </a:extLst>
+          </p:cNvPr>
+          <p:cNvSpPr>
+            <a:spLocks noGrp="1"/>
+          </p:cNvSpPr>
+          <p:nvPr>
+            <p:ph type="dt" sz="half" idx="10"/>
+          </p:nvPr>
+        </p:nvSpPr>
+        <p:spPr/>
+        <p:txBody>
+          <a:bodyPr/>
+          <a:lstStyle/>
+          <a:p>
+            <a:fld id="{A40A2488-620E-4717-952D-4163044243D3}" type="datetime1">
+              <a:rPr lang="da-DK" smtClean="0"/>
+              <a:t>25-04-2026</a:t>
+            </a:fld>
+            <a:endParaRPr lang="da-DK" dirty="0"/>
+          </a:p>
+        </p:txBody>
+      </p:sp>
+      <p:sp>
+        <p:nvSpPr>
+          <p:cNvPr id="5" name="Pladsholder til slidenummer 4">
+            <a:extLst>
+              <a:ext uri="{FF2B5EF4-FFF2-40B4-BE49-F238E27FC236}">
+                <a16:creationId xmlns:a16="http://schemas.microsoft.com/office/drawing/2014/main" id="{B6EB07DD-93DC-B6F8-3848-F4860123CE4D}"/>
+              </a:ext>
+            </a:extLst>
+          </p:cNvPr>
+          <p:cNvSpPr>
+            <a:spLocks noGrp="1"/>
+          </p:cNvSpPr>
+          <p:nvPr>
+            <p:ph type="sldNum" sz="quarter" idx="12"/>
+          </p:nvPr>
+        </p:nvSpPr>
+        <p:spPr/>
+        <p:txBody>
+          <a:bodyPr/>
+          <a:lstStyle/>
+          <a:p>
+            <a:fld id="{091A926C-488A-4E3E-9C21-57CAA120E114}" type="slidenum">
+              <a:rPr lang="da-DK" smtClean="0"/>
+              <a:t>9</a:t>
+            </a:fld>
+            <a:endParaRPr lang="da-DK" dirty="0"/>
+          </a:p>
+        </p:txBody>
+      </p:sp>
+      <p:pic>
+        <p:nvPicPr>
+          <p:cNvPr id="9" name="Billede 8">
+            <a:extLst>
+              <a:ext uri="{FF2B5EF4-FFF2-40B4-BE49-F238E27FC236}">
+                <a16:creationId xmlns:a16="http://schemas.microsoft.com/office/drawing/2014/main" id="{BD820F50-5ECF-2785-0806-8DF0B9B4E2B9}"/>
+              </a:ext>
+            </a:extLst>
+          </p:cNvPr>
+          <p:cNvPicPr>
+            <a:picLocks noChangeAspect="1"/>
+          </p:cNvPicPr>
+          <p:nvPr/>
+        </p:nvPicPr>
+        <p:blipFill>
+          <a:blip r:embed="rId3"/>
+          <a:stretch>
+            <a:fillRect/>
+          </a:stretch>
+        </p:blipFill>
+        <p:spPr>
+          <a:xfrm>
+            <a:off x="5768524" y="1842485"/>
+            <a:ext cx="6015616" cy="3902021"/>
+          </a:xfrm>
+          <a:prstGeom prst="rect">
+            <a:avLst/>
+          </a:prstGeom>
+        </p:spPr>
+      </p:pic>
+    </p:spTree>
+    <p:extLst>
+      <p:ext uri="{BB962C8B-B14F-4D97-AF65-F5344CB8AC3E}">
+        <p14:creationId xmlns:p14="http://schemas.microsoft.com/office/powerpoint/2010/main" val="2218646879"/>
       </p:ext>
     </p:extLst>
   </p:cSld>

</xml_diff>